<commit_message>
Rebrand training artefacts with Getamazednow AI Design System v1.0
- Both decks: navy/teal palette remapped to Ink/Signal/Stone brand tokens,
  Poppins headings, brand badge on title slides (layouts, masters, theme incl.)
- Training guide: heading/title colors to Ink + Signal-deep, theme fonts
  to Poppins (headings) / Inter (body); content untouched
</commit_message>
<xml_diff>
--- a/training/slides/GenAI-Observability-Exec-Overview.pptx
+++ b/training/slides/GenAI-Observability-Exec-Overview.pptx
@@ -2862,7 +2862,7 @@
         <a:spcBef>
           <a:spcPct val="20000"/>
         </a:spcBef>
-        <a:buFont typeface="Arial"/>
+        <a:buFont typeface="Poppins"/>
         <a:buChar char="•"/>
         <a:defRPr sz="3200" kern="1200">
           <a:solidFill>
@@ -2877,7 +2877,7 @@
         <a:spcBef>
           <a:spcPct val="20000"/>
         </a:spcBef>
-        <a:buFont typeface="Arial"/>
+        <a:buFont typeface="Poppins"/>
         <a:buChar char="–"/>
         <a:defRPr sz="2800" kern="1200">
           <a:solidFill>
@@ -2892,7 +2892,7 @@
         <a:spcBef>
           <a:spcPct val="20000"/>
         </a:spcBef>
-        <a:buFont typeface="Arial"/>
+        <a:buFont typeface="Poppins"/>
         <a:buChar char="•"/>
         <a:defRPr sz="2400" kern="1200">
           <a:solidFill>
@@ -2907,7 +2907,7 @@
         <a:spcBef>
           <a:spcPct val="20000"/>
         </a:spcBef>
-        <a:buFont typeface="Arial"/>
+        <a:buFont typeface="Poppins"/>
         <a:buChar char="–"/>
         <a:defRPr sz="2000" kern="1200">
           <a:solidFill>
@@ -2922,7 +2922,7 @@
         <a:spcBef>
           <a:spcPct val="20000"/>
         </a:spcBef>
-        <a:buFont typeface="Arial"/>
+        <a:buFont typeface="Poppins"/>
         <a:buChar char="»"/>
         <a:defRPr sz="2000" kern="1200">
           <a:solidFill>
@@ -2937,7 +2937,7 @@
         <a:spcBef>
           <a:spcPct val="20000"/>
         </a:spcBef>
-        <a:buFont typeface="Arial"/>
+        <a:buFont typeface="Poppins"/>
         <a:buChar char="•"/>
         <a:defRPr sz="2000" kern="1200">
           <a:solidFill>
@@ -2952,7 +2952,7 @@
         <a:spcBef>
           <a:spcPct val="20000"/>
         </a:spcBef>
-        <a:buFont typeface="Arial"/>
+        <a:buFont typeface="Poppins"/>
         <a:buChar char="•"/>
         <a:defRPr sz="2000" kern="1200">
           <a:solidFill>
@@ -2967,7 +2967,7 @@
         <a:spcBef>
           <a:spcPct val="20000"/>
         </a:spcBef>
-        <a:buFont typeface="Arial"/>
+        <a:buFont typeface="Poppins"/>
         <a:buChar char="•"/>
         <a:defRPr sz="2000" kern="1200">
           <a:solidFill>
@@ -2982,7 +2982,7 @@
         <a:spcBef>
           <a:spcPct val="20000"/>
         </a:spcBef>
-        <a:buFont typeface="Arial"/>
+        <a:buFont typeface="Poppins"/>
         <a:buChar char="•"/>
         <a:defRPr sz="2000" kern="1200">
           <a:solidFill>
@@ -3099,7 +3099,7 @@
     <p:bg>
       <p:bgPr>
         <a:solidFill>
-          <a:srgbClr val="16213E"/>
+          <a:srgbClr val="2A363B"/>
         </a:solidFill>
         <a:effectLst/>
       </p:bgPr>
@@ -3126,7 +3126,7 @@
             <a:avLst/>
           </a:prstGeom>
           <a:solidFill>
-            <a:srgbClr val="0F3460"/>
+            <a:srgbClr val="3F474A"/>
           </a:solidFill>
           <a:ln>
             <a:noFill/>
@@ -3170,7 +3170,7 @@
             <a:avLst/>
           </a:prstGeom>
           <a:solidFill>
-            <a:srgbClr val="1F9E97"/>
+            <a:srgbClr val="5FA8CC"/>
           </a:solidFill>
           <a:ln>
             <a:noFill/>
@@ -3229,7 +3229,7 @@
             <a:r>
               <a:rPr sz="1400" b="1" i="0">
                 <a:solidFill>
-                  <a:srgbClr val="1F9E97"/>
+                  <a:srgbClr val="5FA8CC"/>
                 </a:solidFill>
                 <a:latin typeface="Calibri"/>
               </a:rPr>
@@ -3307,7 +3307,7 @@
             <a:r>
               <a:rPr sz="1600" b="0" i="1">
                 <a:solidFill>
-                  <a:srgbClr val="C9D6EC"/>
+                  <a:srgbClr val="C7D3D8"/>
                 </a:solidFill>
                 <a:latin typeface="Calibri"/>
               </a:rPr>
@@ -3333,7 +3333,7 @@
             </a:avLst>
           </a:prstGeom>
           <a:solidFill>
-            <a:srgbClr val="0F3460"/>
+            <a:srgbClr val="3F474A"/>
           </a:solidFill>
           <a:ln>
             <a:noFill/>
@@ -3392,7 +3392,7 @@
             <a:r>
               <a:rPr sz="1150" b="1" i="0">
                 <a:solidFill>
-                  <a:srgbClr val="E0982A"/>
+                  <a:srgbClr val="E3A253"/>
                 </a:solidFill>
                 <a:latin typeface="Calibri"/>
               </a:rPr>
@@ -3431,7 +3431,7 @@
             <a:r>
               <a:rPr sz="1050" b="0" i="0">
                 <a:solidFill>
-                  <a:srgbClr val="8A9BC4"/>
+                  <a:srgbClr val="B7BEC2"/>
                 </a:solidFill>
                 <a:latin typeface="Calibri"/>
               </a:rPr>
@@ -3440,6 +3440,28 @@
           </a:p>
         </p:txBody>
       </p:sp>
+      <p:pic>
+        <p:nvPicPr>
+          <p:cNvPr id="900" name="Getamazednow AI badge"/>
+          <p:cNvPicPr/>
+          <p:nvPr/>
+        </p:nvPicPr>
+        <p:blipFill>
+          <a:blip r:embed="rIdGaiLogo"/>
+          <a:stretch>
+            <a:fillRect/>
+          </a:stretch>
+        </p:blipFill>
+        <p:spPr>
+          <a:xfrm>
+            <a:off x="10896295" y="457200"/>
+            <a:ext cx="838200" cy="838200"/>
+          </a:xfrm>
+          <a:prstGeom prst="rect">
+            <a:avLst/>
+          </a:prstGeom>
+        </p:spPr>
+      </p:pic>
     </p:spTree>
   </p:cSld>
   <p:clrMapOvr>
@@ -3496,7 +3518,7 @@
             <a:r>
               <a:rPr sz="1150" b="1" i="0">
                 <a:solidFill>
-                  <a:srgbClr val="1F9E97"/>
+                  <a:srgbClr val="5FA8CC"/>
                 </a:solidFill>
                 <a:latin typeface="Calibri"/>
               </a:rPr>
@@ -3535,7 +3557,7 @@
             <a:r>
               <a:rPr sz="2600" b="1" i="0">
                 <a:solidFill>
-                  <a:srgbClr val="16213E"/>
+                  <a:srgbClr val="2A363B"/>
                 </a:solidFill>
                 <a:latin typeface="Calibri"/>
               </a:rPr>
@@ -3574,7 +3596,7 @@
             <a:r>
               <a:rPr sz="900" b="0" i="0">
                 <a:solidFill>
-                  <a:srgbClr val="8592A6"/>
+                  <a:srgbClr val="8A97A0"/>
                 </a:solidFill>
                 <a:latin typeface="Calibri"/>
               </a:rPr>
@@ -3613,7 +3635,7 @@
             <a:r>
               <a:rPr sz="900" b="0" i="0">
                 <a:solidFill>
-                  <a:srgbClr val="8592A6"/>
+                  <a:srgbClr val="8A97A0"/>
                 </a:solidFill>
                 <a:latin typeface="Calibri"/>
               </a:rPr>
@@ -3651,13 +3673,13 @@
               <a:spcAft>
                 <a:spcPts val="1400"/>
               </a:spcAft>
-              <a:buFont typeface="Arial"/>
+              <a:buFont typeface="Poppins"/>
               <a:buChar char="•"/>
             </a:pPr>
             <a:r>
               <a:rPr b="1" sz="1350">
                 <a:solidFill>
-                  <a:srgbClr val="222222"/>
+                  <a:srgbClr val="2C3234"/>
                 </a:solidFill>
                 <a:latin typeface="Calibri"/>
               </a:rPr>
@@ -3666,7 +3688,7 @@
             <a:r>
               <a:rPr sz="1350">
                 <a:solidFill>
-                  <a:srgbClr val="222222"/>
+                  <a:srgbClr val="2C3234"/>
                 </a:solidFill>
                 <a:latin typeface="Calibri"/>
               </a:rPr>
@@ -3681,13 +3703,13 @@
               <a:spcAft>
                 <a:spcPts val="1400"/>
               </a:spcAft>
-              <a:buFont typeface="Arial"/>
+              <a:buFont typeface="Poppins"/>
               <a:buChar char="•"/>
             </a:pPr>
             <a:r>
               <a:rPr b="1" sz="1350">
                 <a:solidFill>
-                  <a:srgbClr val="222222"/>
+                  <a:srgbClr val="2C3234"/>
                 </a:solidFill>
                 <a:latin typeface="Calibri"/>
               </a:rPr>
@@ -3696,7 +3718,7 @@
             <a:r>
               <a:rPr sz="1350">
                 <a:solidFill>
-                  <a:srgbClr val="222222"/>
+                  <a:srgbClr val="2C3234"/>
                 </a:solidFill>
                 <a:latin typeface="Calibri"/>
               </a:rPr>
@@ -3711,13 +3733,13 @@
               <a:spcAft>
                 <a:spcPts val="1400"/>
               </a:spcAft>
-              <a:buFont typeface="Arial"/>
+              <a:buFont typeface="Poppins"/>
               <a:buChar char="•"/>
             </a:pPr>
             <a:r>
               <a:rPr b="1" sz="1350">
                 <a:solidFill>
-                  <a:srgbClr val="222222"/>
+                  <a:srgbClr val="2C3234"/>
                 </a:solidFill>
                 <a:latin typeface="Calibri"/>
               </a:rPr>
@@ -3726,7 +3748,7 @@
             <a:r>
               <a:rPr sz="1350">
                 <a:solidFill>
-                  <a:srgbClr val="222222"/>
+                  <a:srgbClr val="2C3234"/>
                 </a:solidFill>
                 <a:latin typeface="Calibri"/>
               </a:rPr>
@@ -3741,13 +3763,13 @@
               <a:spcAft>
                 <a:spcPts val="1400"/>
               </a:spcAft>
-              <a:buFont typeface="Arial"/>
+              <a:buFont typeface="Poppins"/>
               <a:buChar char="•"/>
             </a:pPr>
             <a:r>
               <a:rPr b="1" sz="1350">
                 <a:solidFill>
-                  <a:srgbClr val="222222"/>
+                  <a:srgbClr val="2C3234"/>
                 </a:solidFill>
                 <a:latin typeface="Calibri"/>
               </a:rPr>
@@ -3756,7 +3778,7 @@
             <a:r>
               <a:rPr sz="1350">
                 <a:solidFill>
-                  <a:srgbClr val="222222"/>
+                  <a:srgbClr val="2C3234"/>
                 </a:solidFill>
                 <a:latin typeface="Calibri"/>
               </a:rPr>
@@ -3771,13 +3793,13 @@
               <a:spcAft>
                 <a:spcPts val="1400"/>
               </a:spcAft>
-              <a:buFont typeface="Arial"/>
+              <a:buFont typeface="Poppins"/>
               <a:buChar char="•"/>
             </a:pPr>
             <a:r>
               <a:rPr b="1" sz="1350">
                 <a:solidFill>
-                  <a:srgbClr val="222222"/>
+                  <a:srgbClr val="2C3234"/>
                 </a:solidFill>
                 <a:latin typeface="Calibri"/>
               </a:rPr>
@@ -3786,7 +3808,7 @@
             <a:r>
               <a:rPr sz="1350">
                 <a:solidFill>
-                  <a:srgbClr val="222222"/>
+                  <a:srgbClr val="2C3234"/>
                 </a:solidFill>
                 <a:latin typeface="Calibri"/>
               </a:rPr>
@@ -3812,7 +3834,7 @@
             </a:avLst>
           </a:prstGeom>
           <a:solidFill>
-            <a:srgbClr val="16213E"/>
+            <a:srgbClr val="2A363B"/>
           </a:solidFill>
           <a:ln>
             <a:noFill/>
@@ -3820,7 +3842,7 @@
           <a:effectLst/>
           <a:effectLst>
             <a:outerShdw blurRad="90000" dist="30000" dir="5400000" rotWithShape="0">
-              <a:srgbClr val="16213E">
+              <a:srgbClr val="2A363B">
                 <a:alpha val="20000"/>
               </a:srgbClr>
             </a:outerShdw>
@@ -3878,7 +3900,7 @@
             <a:r>
               <a:rPr sz="1100" b="1" i="0">
                 <a:solidFill>
-                  <a:srgbClr val="1F9E97"/>
+                  <a:srgbClr val="5FA8CC"/>
                 </a:solidFill>
                 <a:latin typeface="Calibri"/>
               </a:rPr>
@@ -3988,7 +4010,7 @@
             <a:r>
               <a:rPr sz="1100" b="0" i="0">
                 <a:solidFill>
-                  <a:srgbClr val="C9D6EC"/>
+                  <a:srgbClr val="C7D3D8"/>
                 </a:solidFill>
                 <a:latin typeface="Calibri"/>
               </a:rPr>
@@ -4011,7 +4033,7 @@
     <p:bg>
       <p:bgPr>
         <a:solidFill>
-          <a:srgbClr val="16213E"/>
+          <a:srgbClr val="2A363B"/>
         </a:solidFill>
         <a:effectLst/>
       </p:bgPr>
@@ -4038,7 +4060,7 @@
             <a:avLst/>
           </a:prstGeom>
           <a:solidFill>
-            <a:srgbClr val="0F3460"/>
+            <a:srgbClr val="3F474A"/>
           </a:solidFill>
           <a:ln>
             <a:noFill/>
@@ -4097,7 +4119,7 @@
             <a:r>
               <a:rPr sz="6400" b="1" i="0">
                 <a:solidFill>
-                  <a:srgbClr val="1F9E97"/>
+                  <a:srgbClr val="5FA8CC"/>
                 </a:solidFill>
                 <a:latin typeface="Calibri"/>
               </a:rPr>
@@ -4175,7 +4197,7 @@
             <a:r>
               <a:rPr sz="1500" b="0" i="1">
                 <a:solidFill>
-                  <a:srgbClr val="C9D6EC"/>
+                  <a:srgbClr val="C7D3D8"/>
                 </a:solidFill>
                 <a:latin typeface="Calibri"/>
               </a:rPr>
@@ -4214,7 +4236,7 @@
             <a:r>
               <a:rPr sz="900" b="0" i="0">
                 <a:solidFill>
-                  <a:srgbClr val="B8C2D6"/>
+                  <a:srgbClr val="B7BEC2"/>
                 </a:solidFill>
                 <a:latin typeface="Calibri"/>
               </a:rPr>
@@ -4279,7 +4301,7 @@
             <a:r>
               <a:rPr sz="1150" b="1" i="0">
                 <a:solidFill>
-                  <a:srgbClr val="1F9E97"/>
+                  <a:srgbClr val="5FA8CC"/>
                 </a:solidFill>
                 <a:latin typeface="Calibri"/>
               </a:rPr>
@@ -4318,7 +4340,7 @@
             <a:r>
               <a:rPr sz="2600" b="1" i="0">
                 <a:solidFill>
-                  <a:srgbClr val="16213E"/>
+                  <a:srgbClr val="2A363B"/>
                 </a:solidFill>
                 <a:latin typeface="Calibri"/>
               </a:rPr>
@@ -4357,7 +4379,7 @@
             <a:r>
               <a:rPr sz="900" b="0" i="0">
                 <a:solidFill>
-                  <a:srgbClr val="8592A6"/>
+                  <a:srgbClr val="8A97A0"/>
                 </a:solidFill>
                 <a:latin typeface="Calibri"/>
               </a:rPr>
@@ -4396,7 +4418,7 @@
             <a:r>
               <a:rPr sz="900" b="0" i="0">
                 <a:solidFill>
-                  <a:srgbClr val="8592A6"/>
+                  <a:srgbClr val="8A97A0"/>
                 </a:solidFill>
                 <a:latin typeface="Calibri"/>
               </a:rPr>
@@ -4446,7 +4468,7 @@
             </a:avLst>
           </a:prstGeom>
           <a:solidFill>
-            <a:srgbClr val="F6F7F9"/>
+            <a:srgbClr val="F6F7F7"/>
           </a:solidFill>
           <a:ln>
             <a:noFill/>
@@ -4454,7 +4476,7 @@
           <a:effectLst/>
           <a:effectLst>
             <a:outerShdw blurRad="90000" dist="30000" dir="5400000" rotWithShape="0">
-              <a:srgbClr val="16213E">
+              <a:srgbClr val="2A363B">
                 <a:alpha val="20000"/>
               </a:srgbClr>
             </a:outerShdw>
@@ -4512,7 +4534,7 @@
             <a:r>
               <a:rPr sz="1200" b="1" i="0">
                 <a:solidFill>
-                  <a:srgbClr val="1F9E97"/>
+                  <a:srgbClr val="5FA8CC"/>
                 </a:solidFill>
                 <a:latin typeface="Calibri"/>
               </a:rPr>
@@ -4551,7 +4573,7 @@
             <a:r>
               <a:rPr sz="1200" b="0" i="0">
                 <a:solidFill>
-                  <a:srgbClr val="3E5C76"/>
+                  <a:srgbClr val="545E63"/>
                 </a:solidFill>
                 <a:latin typeface="Calibri"/>
               </a:rPr>
@@ -4567,7 +4589,7 @@
             <a:r>
               <a:rPr sz="1200" b="0" i="0">
                 <a:solidFill>
-                  <a:srgbClr val="3E5C76"/>
+                  <a:srgbClr val="545E63"/>
                 </a:solidFill>
                 <a:latin typeface="Calibri"/>
               </a:rPr>
@@ -4583,7 +4605,7 @@
             <a:r>
               <a:rPr sz="1200" b="0" i="0">
                 <a:solidFill>
-                  <a:srgbClr val="3E5C76"/>
+                  <a:srgbClr val="545E63"/>
                 </a:solidFill>
                 <a:latin typeface="Calibri"/>
               </a:rPr>
@@ -4599,7 +4621,7 @@
             <a:r>
               <a:rPr sz="1200" b="0" i="0">
                 <a:solidFill>
-                  <a:srgbClr val="3E5C76"/>
+                  <a:srgbClr val="545E63"/>
                 </a:solidFill>
                 <a:latin typeface="Calibri"/>
               </a:rPr>
@@ -4615,7 +4637,7 @@
             <a:r>
               <a:rPr sz="1200" b="0" i="0">
                 <a:solidFill>
-                  <a:srgbClr val="3E5C76"/>
+                  <a:srgbClr val="545E63"/>
                 </a:solidFill>
                 <a:latin typeface="Calibri"/>
               </a:rPr>
@@ -4680,7 +4702,7 @@
             <a:r>
               <a:rPr sz="1150" b="1" i="0">
                 <a:solidFill>
-                  <a:srgbClr val="1F9E97"/>
+                  <a:srgbClr val="5FA8CC"/>
                 </a:solidFill>
                 <a:latin typeface="Calibri"/>
               </a:rPr>
@@ -4719,7 +4741,7 @@
             <a:r>
               <a:rPr sz="2600" b="1" i="0">
                 <a:solidFill>
-                  <a:srgbClr val="16213E"/>
+                  <a:srgbClr val="2A363B"/>
                 </a:solidFill>
                 <a:latin typeface="Calibri"/>
               </a:rPr>
@@ -4758,7 +4780,7 @@
             <a:r>
               <a:rPr sz="900" b="0" i="0">
                 <a:solidFill>
-                  <a:srgbClr val="8592A6"/>
+                  <a:srgbClr val="8A97A0"/>
                 </a:solidFill>
                 <a:latin typeface="Calibri"/>
               </a:rPr>
@@ -4797,7 +4819,7 @@
             <a:r>
               <a:rPr sz="900" b="0" i="0">
                 <a:solidFill>
-                  <a:srgbClr val="8592A6"/>
+                  <a:srgbClr val="8A97A0"/>
                 </a:solidFill>
                 <a:latin typeface="Calibri"/>
               </a:rPr>
@@ -4831,7 +4853,7 @@
           <a:effectLst/>
           <a:effectLst>
             <a:outerShdw blurRad="90000" dist="30000" dir="5400000" rotWithShape="0">
-              <a:srgbClr val="16213E">
+              <a:srgbClr val="2A363B">
                 <a:alpha val="20000"/>
               </a:srgbClr>
             </a:outerShdw>
@@ -4874,7 +4896,7 @@
             <a:avLst/>
           </a:prstGeom>
           <a:solidFill>
-            <a:srgbClr val="E0982A"/>
+            <a:srgbClr val="E3A253"/>
           </a:solidFill>
           <a:ln>
             <a:noFill/>
@@ -4933,7 +4955,7 @@
             <a:r>
               <a:rPr sz="1700" b="1" i="0">
                 <a:solidFill>
-                  <a:srgbClr val="16213E"/>
+                  <a:srgbClr val="2A363B"/>
                 </a:solidFill>
                 <a:latin typeface="Calibri"/>
               </a:rPr>
@@ -4972,7 +4994,7 @@
             <a:r>
               <a:rPr sz="1350" b="0" i="0">
                 <a:solidFill>
-                  <a:srgbClr val="222222"/>
+                  <a:srgbClr val="2C3234"/>
                 </a:solidFill>
                 <a:latin typeface="Calibri"/>
               </a:rPr>
@@ -5011,7 +5033,7 @@
             <a:r>
               <a:rPr sz="1300" b="0" i="1">
                 <a:solidFill>
-                  <a:srgbClr val="16213E"/>
+                  <a:srgbClr val="2A363B"/>
                 </a:solidFill>
                 <a:latin typeface="Calibri"/>
               </a:rPr>
@@ -5034,7 +5056,7 @@
     <p:bg>
       <p:bgPr>
         <a:solidFill>
-          <a:srgbClr val="16213E"/>
+          <a:srgbClr val="2A363B"/>
         </a:solidFill>
         <a:effectLst/>
       </p:bgPr>
@@ -5061,7 +5083,7 @@
             <a:avLst/>
           </a:prstGeom>
           <a:solidFill>
-            <a:srgbClr val="0F3460"/>
+            <a:srgbClr val="3F474A"/>
           </a:solidFill>
           <a:ln>
             <a:noFill/>
@@ -5120,7 +5142,7 @@
             <a:r>
               <a:rPr sz="6400" b="1" i="0">
                 <a:solidFill>
-                  <a:srgbClr val="1F9E97"/>
+                  <a:srgbClr val="5FA8CC"/>
                 </a:solidFill>
                 <a:latin typeface="Calibri"/>
               </a:rPr>
@@ -5198,7 +5220,7 @@
             <a:r>
               <a:rPr sz="1500" b="0" i="1">
                 <a:solidFill>
-                  <a:srgbClr val="C9D6EC"/>
+                  <a:srgbClr val="C7D3D8"/>
                 </a:solidFill>
                 <a:latin typeface="Calibri"/>
               </a:rPr>
@@ -5237,7 +5259,7 @@
             <a:r>
               <a:rPr sz="900" b="0" i="0">
                 <a:solidFill>
-                  <a:srgbClr val="B8C2D6"/>
+                  <a:srgbClr val="B7BEC2"/>
                 </a:solidFill>
                 <a:latin typeface="Calibri"/>
               </a:rPr>
@@ -5302,7 +5324,7 @@
             <a:r>
               <a:rPr sz="1150" b="1" i="0">
                 <a:solidFill>
-                  <a:srgbClr val="1F9E97"/>
+                  <a:srgbClr val="5FA8CC"/>
                 </a:solidFill>
                 <a:latin typeface="Calibri"/>
               </a:rPr>
@@ -5341,7 +5363,7 @@
             <a:r>
               <a:rPr sz="2600" b="1" i="0">
                 <a:solidFill>
-                  <a:srgbClr val="16213E"/>
+                  <a:srgbClr val="2A363B"/>
                 </a:solidFill>
                 <a:latin typeface="Calibri"/>
               </a:rPr>
@@ -5380,7 +5402,7 @@
             <a:r>
               <a:rPr sz="900" b="0" i="0">
                 <a:solidFill>
-                  <a:srgbClr val="8592A6"/>
+                  <a:srgbClr val="8A97A0"/>
                 </a:solidFill>
                 <a:latin typeface="Calibri"/>
               </a:rPr>
@@ -5419,7 +5441,7 @@
             <a:r>
               <a:rPr sz="900" b="0" i="0">
                 <a:solidFill>
-                  <a:srgbClr val="8592A6"/>
+                  <a:srgbClr val="8A97A0"/>
                 </a:solidFill>
                 <a:latin typeface="Calibri"/>
               </a:rPr>
@@ -5508,7 +5530,7 @@
             <a:r>
               <a:rPr sz="1150" b="1" i="0">
                 <a:solidFill>
-                  <a:srgbClr val="1F9E97"/>
+                  <a:srgbClr val="5FA8CC"/>
                 </a:solidFill>
                 <a:latin typeface="Calibri"/>
               </a:rPr>
@@ -5547,7 +5569,7 @@
             <a:r>
               <a:rPr sz="2600" b="1" i="0">
                 <a:solidFill>
-                  <a:srgbClr val="16213E"/>
+                  <a:srgbClr val="2A363B"/>
                 </a:solidFill>
                 <a:latin typeface="Calibri"/>
               </a:rPr>
@@ -5586,7 +5608,7 @@
             <a:r>
               <a:rPr sz="900" b="0" i="0">
                 <a:solidFill>
-                  <a:srgbClr val="8592A6"/>
+                  <a:srgbClr val="8A97A0"/>
                 </a:solidFill>
                 <a:latin typeface="Calibri"/>
               </a:rPr>
@@ -5625,7 +5647,7 @@
             <a:r>
               <a:rPr sz="900" b="0" i="0">
                 <a:solidFill>
-                  <a:srgbClr val="8592A6"/>
+                  <a:srgbClr val="8A97A0"/>
                 </a:solidFill>
                 <a:latin typeface="Calibri"/>
               </a:rPr>
@@ -5664,7 +5686,7 @@
             <a:r>
               <a:rPr sz="1250" b="1" i="0">
                 <a:solidFill>
-                  <a:srgbClr val="1F9E97"/>
+                  <a:srgbClr val="5FA8CC"/>
                 </a:solidFill>
                 <a:latin typeface="Calibri"/>
               </a:rPr>
@@ -5702,13 +5724,13 @@
               <a:spcAft>
                 <a:spcPts val="1200"/>
               </a:spcAft>
-              <a:buFont typeface="Arial"/>
+              <a:buFont typeface="Poppins"/>
               <a:buChar char="•"/>
             </a:pPr>
             <a:r>
               <a:rPr sz="1250">
                 <a:solidFill>
-                  <a:srgbClr val="222222"/>
+                  <a:srgbClr val="2C3234"/>
                 </a:solidFill>
                 <a:latin typeface="Calibri"/>
               </a:rPr>
@@ -5723,13 +5745,13 @@
               <a:spcAft>
                 <a:spcPts val="1200"/>
               </a:spcAft>
-              <a:buFont typeface="Arial"/>
+              <a:buFont typeface="Poppins"/>
               <a:buChar char="•"/>
             </a:pPr>
             <a:r>
               <a:rPr sz="1250">
                 <a:solidFill>
-                  <a:srgbClr val="222222"/>
+                  <a:srgbClr val="2C3234"/>
                 </a:solidFill>
                 <a:latin typeface="Calibri"/>
               </a:rPr>
@@ -5744,13 +5766,13 @@
               <a:spcAft>
                 <a:spcPts val="1200"/>
               </a:spcAft>
-              <a:buFont typeface="Arial"/>
+              <a:buFont typeface="Poppins"/>
               <a:buChar char="•"/>
             </a:pPr>
             <a:r>
               <a:rPr sz="1250">
                 <a:solidFill>
-                  <a:srgbClr val="222222"/>
+                  <a:srgbClr val="2C3234"/>
                 </a:solidFill>
                 <a:latin typeface="Calibri"/>
               </a:rPr>
@@ -5765,13 +5787,13 @@
               <a:spcAft>
                 <a:spcPts val="1200"/>
               </a:spcAft>
-              <a:buFont typeface="Arial"/>
+              <a:buFont typeface="Poppins"/>
               <a:buChar char="•"/>
             </a:pPr>
             <a:r>
               <a:rPr sz="1250">
                 <a:solidFill>
-                  <a:srgbClr val="222222"/>
+                  <a:srgbClr val="2C3234"/>
                 </a:solidFill>
                 <a:latin typeface="Calibri"/>
               </a:rPr>
@@ -5810,7 +5832,7 @@
             <a:r>
               <a:rPr sz="1250" b="1" i="0">
                 <a:solidFill>
-                  <a:srgbClr val="1F9E97"/>
+                  <a:srgbClr val="5FA8CC"/>
                 </a:solidFill>
                 <a:latin typeface="Calibri"/>
               </a:rPr>
@@ -5848,13 +5870,13 @@
               <a:spcAft>
                 <a:spcPts val="1000"/>
               </a:spcAft>
-              <a:buFont typeface="Arial"/>
+              <a:buFont typeface="Poppins"/>
               <a:buChar char="•"/>
             </a:pPr>
             <a:r>
               <a:rPr sz="1250">
                 <a:solidFill>
-                  <a:srgbClr val="222222"/>
+                  <a:srgbClr val="2C3234"/>
                 </a:solidFill>
                 <a:latin typeface="Calibri"/>
               </a:rPr>
@@ -5869,13 +5891,13 @@
               <a:spcAft>
                 <a:spcPts val="1000"/>
               </a:spcAft>
-              <a:buFont typeface="Arial"/>
+              <a:buFont typeface="Poppins"/>
               <a:buChar char="•"/>
             </a:pPr>
             <a:r>
               <a:rPr sz="1250">
                 <a:solidFill>
-                  <a:srgbClr val="222222"/>
+                  <a:srgbClr val="2C3234"/>
                 </a:solidFill>
                 <a:latin typeface="Calibri"/>
               </a:rPr>
@@ -5890,13 +5912,13 @@
               <a:spcAft>
                 <a:spcPts val="1000"/>
               </a:spcAft>
-              <a:buFont typeface="Arial"/>
+              <a:buFont typeface="Poppins"/>
               <a:buChar char="•"/>
             </a:pPr>
             <a:r>
               <a:rPr sz="1250">
                 <a:solidFill>
-                  <a:srgbClr val="222222"/>
+                  <a:srgbClr val="2C3234"/>
                 </a:solidFill>
                 <a:latin typeface="Calibri"/>
               </a:rPr>
@@ -5911,13 +5933,13 @@
               <a:spcAft>
                 <a:spcPts val="1000"/>
               </a:spcAft>
-              <a:buFont typeface="Arial"/>
+              <a:buFont typeface="Poppins"/>
               <a:buChar char="•"/>
             </a:pPr>
             <a:r>
               <a:rPr sz="1250">
                 <a:solidFill>
-                  <a:srgbClr val="222222"/>
+                  <a:srgbClr val="2C3234"/>
                 </a:solidFill>
                 <a:latin typeface="Calibri"/>
               </a:rPr>
@@ -5932,13 +5954,13 @@
               <a:spcAft>
                 <a:spcPts val="1000"/>
               </a:spcAft>
-              <a:buFont typeface="Arial"/>
+              <a:buFont typeface="Poppins"/>
               <a:buChar char="•"/>
             </a:pPr>
             <a:r>
               <a:rPr sz="1250">
                 <a:solidFill>
-                  <a:srgbClr val="222222"/>
+                  <a:srgbClr val="2C3234"/>
                 </a:solidFill>
                 <a:latin typeface="Calibri"/>
               </a:rPr>
@@ -5964,7 +5986,7 @@
             </a:avLst>
           </a:prstGeom>
           <a:solidFill>
-            <a:srgbClr val="16213E"/>
+            <a:srgbClr val="2A363B"/>
           </a:solidFill>
           <a:ln>
             <a:noFill/>
@@ -6088,7 +6110,7 @@
             <a:r>
               <a:rPr sz="1150" b="1" i="0">
                 <a:solidFill>
-                  <a:srgbClr val="1F9E97"/>
+                  <a:srgbClr val="5FA8CC"/>
                 </a:solidFill>
                 <a:latin typeface="Calibri"/>
               </a:rPr>
@@ -6127,7 +6149,7 @@
             <a:r>
               <a:rPr sz="2600" b="1" i="0">
                 <a:solidFill>
-                  <a:srgbClr val="16213E"/>
+                  <a:srgbClr val="2A363B"/>
                 </a:solidFill>
                 <a:latin typeface="Calibri"/>
               </a:rPr>
@@ -6166,7 +6188,7 @@
             <a:r>
               <a:rPr sz="900" b="0" i="0">
                 <a:solidFill>
-                  <a:srgbClr val="8592A6"/>
+                  <a:srgbClr val="8A97A0"/>
                 </a:solidFill>
                 <a:latin typeface="Calibri"/>
               </a:rPr>
@@ -6205,7 +6227,7 @@
             <a:r>
               <a:rPr sz="900" b="0" i="0">
                 <a:solidFill>
-                  <a:srgbClr val="8592A6"/>
+                  <a:srgbClr val="8A97A0"/>
                 </a:solidFill>
                 <a:latin typeface="Calibri"/>
               </a:rPr>
@@ -6231,7 +6253,7 @@
             </a:avLst>
           </a:prstGeom>
           <a:solidFill>
-            <a:srgbClr val="F6F7F9"/>
+            <a:srgbClr val="F6F7F7"/>
           </a:solidFill>
           <a:ln>
             <a:noFill/>
@@ -6239,7 +6261,7 @@
           <a:effectLst/>
           <a:effectLst>
             <a:outerShdw blurRad="90000" dist="30000" dir="5400000" rotWithShape="0">
-              <a:srgbClr val="16213E">
+              <a:srgbClr val="2A363B">
                 <a:alpha val="20000"/>
               </a:srgbClr>
             </a:outerShdw>
@@ -6297,7 +6319,7 @@
             <a:r>
               <a:rPr sz="3000" b="1" i="0">
                 <a:solidFill>
-                  <a:srgbClr val="1F9E97"/>
+                  <a:srgbClr val="5FA8CC"/>
                 </a:solidFill>
                 <a:latin typeface="Calibri"/>
               </a:rPr>
@@ -6336,7 +6358,7 @@
             <a:r>
               <a:rPr sz="1700" b="1" i="0">
                 <a:solidFill>
-                  <a:srgbClr val="16213E"/>
+                  <a:srgbClr val="2A363B"/>
                 </a:solidFill>
                 <a:latin typeface="Calibri"/>
               </a:rPr>
@@ -6375,7 +6397,7 @@
             <a:r>
               <a:rPr sz="1200" b="0" i="0">
                 <a:solidFill>
-                  <a:srgbClr val="3E5C76"/>
+                  <a:srgbClr val="545E63"/>
                 </a:solidFill>
                 <a:latin typeface="Calibri"/>
               </a:rPr>
@@ -6401,7 +6423,7 @@
             </a:avLst>
           </a:prstGeom>
           <a:solidFill>
-            <a:srgbClr val="F6F7F9"/>
+            <a:srgbClr val="F6F7F7"/>
           </a:solidFill>
           <a:ln>
             <a:noFill/>
@@ -6409,7 +6431,7 @@
           <a:effectLst/>
           <a:effectLst>
             <a:outerShdw blurRad="90000" dist="30000" dir="5400000" rotWithShape="0">
-              <a:srgbClr val="16213E">
+              <a:srgbClr val="2A363B">
                 <a:alpha val="20000"/>
               </a:srgbClr>
             </a:outerShdw>
@@ -6467,7 +6489,7 @@
             <a:r>
               <a:rPr sz="3000" b="1" i="0">
                 <a:solidFill>
-                  <a:srgbClr val="1F9E97"/>
+                  <a:srgbClr val="5FA8CC"/>
                 </a:solidFill>
                 <a:latin typeface="Calibri"/>
               </a:rPr>
@@ -6506,7 +6528,7 @@
             <a:r>
               <a:rPr sz="1700" b="1" i="0">
                 <a:solidFill>
-                  <a:srgbClr val="16213E"/>
+                  <a:srgbClr val="2A363B"/>
                 </a:solidFill>
                 <a:latin typeface="Calibri"/>
               </a:rPr>
@@ -6545,7 +6567,7 @@
             <a:r>
               <a:rPr sz="1200" b="0" i="0">
                 <a:solidFill>
-                  <a:srgbClr val="3E5C76"/>
+                  <a:srgbClr val="545E63"/>
                 </a:solidFill>
                 <a:latin typeface="Calibri"/>
               </a:rPr>
@@ -6571,7 +6593,7 @@
             </a:avLst>
           </a:prstGeom>
           <a:solidFill>
-            <a:srgbClr val="F6F7F9"/>
+            <a:srgbClr val="F6F7F7"/>
           </a:solidFill>
           <a:ln>
             <a:noFill/>
@@ -6579,7 +6601,7 @@
           <a:effectLst/>
           <a:effectLst>
             <a:outerShdw blurRad="90000" dist="30000" dir="5400000" rotWithShape="0">
-              <a:srgbClr val="16213E">
+              <a:srgbClr val="2A363B">
                 <a:alpha val="20000"/>
               </a:srgbClr>
             </a:outerShdw>
@@ -6637,7 +6659,7 @@
             <a:r>
               <a:rPr sz="3000" b="1" i="0">
                 <a:solidFill>
-                  <a:srgbClr val="1F9E97"/>
+                  <a:srgbClr val="5FA8CC"/>
                 </a:solidFill>
                 <a:latin typeface="Calibri"/>
               </a:rPr>
@@ -6676,7 +6698,7 @@
             <a:r>
               <a:rPr sz="1700" b="1" i="0">
                 <a:solidFill>
-                  <a:srgbClr val="16213E"/>
+                  <a:srgbClr val="2A363B"/>
                 </a:solidFill>
                 <a:latin typeface="Calibri"/>
               </a:rPr>
@@ -6715,7 +6737,7 @@
             <a:r>
               <a:rPr sz="1200" b="0" i="0">
                 <a:solidFill>
-                  <a:srgbClr val="3E5C76"/>
+                  <a:srgbClr val="545E63"/>
                 </a:solidFill>
                 <a:latin typeface="Calibri"/>
               </a:rPr>
@@ -6741,7 +6763,7 @@
             </a:avLst>
           </a:prstGeom>
           <a:solidFill>
-            <a:srgbClr val="F6F7F9"/>
+            <a:srgbClr val="F6F7F7"/>
           </a:solidFill>
           <a:ln>
             <a:noFill/>
@@ -6749,7 +6771,7 @@
           <a:effectLst/>
           <a:effectLst>
             <a:outerShdw blurRad="90000" dist="30000" dir="5400000" rotWithShape="0">
-              <a:srgbClr val="16213E">
+              <a:srgbClr val="2A363B">
                 <a:alpha val="20000"/>
               </a:srgbClr>
             </a:outerShdw>
@@ -6807,7 +6829,7 @@
             <a:r>
               <a:rPr sz="3000" b="1" i="0">
                 <a:solidFill>
-                  <a:srgbClr val="1F9E97"/>
+                  <a:srgbClr val="5FA8CC"/>
                 </a:solidFill>
                 <a:latin typeface="Calibri"/>
               </a:rPr>
@@ -6846,7 +6868,7 @@
             <a:r>
               <a:rPr sz="1700" b="1" i="0">
                 <a:solidFill>
-                  <a:srgbClr val="16213E"/>
+                  <a:srgbClr val="2A363B"/>
                 </a:solidFill>
                 <a:latin typeface="Calibri"/>
               </a:rPr>
@@ -6885,7 +6907,7 @@
             <a:r>
               <a:rPr sz="1200" b="0" i="0">
                 <a:solidFill>
-                  <a:srgbClr val="3E5C76"/>
+                  <a:srgbClr val="545E63"/>
                 </a:solidFill>
                 <a:latin typeface="Calibri"/>
               </a:rPr>
@@ -6908,7 +6930,7 @@
     <p:bg>
       <p:bgPr>
         <a:solidFill>
-          <a:srgbClr val="16213E"/>
+          <a:srgbClr val="2A363B"/>
         </a:solidFill>
         <a:effectLst/>
       </p:bgPr>
@@ -6935,7 +6957,7 @@
             <a:avLst/>
           </a:prstGeom>
           <a:solidFill>
-            <a:srgbClr val="0F3460"/>
+            <a:srgbClr val="3F474A"/>
           </a:solidFill>
           <a:ln>
             <a:noFill/>
@@ -6994,7 +7016,7 @@
             <a:r>
               <a:rPr sz="6400" b="1" i="0">
                 <a:solidFill>
-                  <a:srgbClr val="1F9E97"/>
+                  <a:srgbClr val="5FA8CC"/>
                 </a:solidFill>
                 <a:latin typeface="Calibri"/>
               </a:rPr>
@@ -7072,7 +7094,7 @@
             <a:r>
               <a:rPr sz="1500" b="0" i="1">
                 <a:solidFill>
-                  <a:srgbClr val="C9D6EC"/>
+                  <a:srgbClr val="C7D3D8"/>
                 </a:solidFill>
                 <a:latin typeface="Calibri"/>
               </a:rPr>
@@ -7111,7 +7133,7 @@
             <a:r>
               <a:rPr sz="900" b="0" i="0">
                 <a:solidFill>
-                  <a:srgbClr val="B8C2D6"/>
+                  <a:srgbClr val="B7BEC2"/>
                 </a:solidFill>
                 <a:latin typeface="Calibri"/>
               </a:rPr>
@@ -7176,7 +7198,7 @@
             <a:r>
               <a:rPr sz="1150" b="1" i="0">
                 <a:solidFill>
-                  <a:srgbClr val="1F9E97"/>
+                  <a:srgbClr val="5FA8CC"/>
                 </a:solidFill>
                 <a:latin typeface="Calibri"/>
               </a:rPr>
@@ -7215,7 +7237,7 @@
             <a:r>
               <a:rPr sz="2600" b="1" i="0">
                 <a:solidFill>
-                  <a:srgbClr val="16213E"/>
+                  <a:srgbClr val="2A363B"/>
                 </a:solidFill>
                 <a:latin typeface="Calibri"/>
               </a:rPr>
@@ -7254,7 +7276,7 @@
             <a:r>
               <a:rPr sz="900" b="0" i="0">
                 <a:solidFill>
-                  <a:srgbClr val="8592A6"/>
+                  <a:srgbClr val="8A97A0"/>
                 </a:solidFill>
                 <a:latin typeface="Calibri"/>
               </a:rPr>
@@ -7293,7 +7315,7 @@
             <a:r>
               <a:rPr sz="900" b="0" i="0">
                 <a:solidFill>
-                  <a:srgbClr val="8592A6"/>
+                  <a:srgbClr val="8A97A0"/>
                 </a:solidFill>
                 <a:latin typeface="Calibri"/>
               </a:rPr>
@@ -7332,7 +7354,7 @@
             <a:r>
               <a:rPr sz="1300" b="0" i="0">
                 <a:solidFill>
-                  <a:srgbClr val="3E5C76"/>
+                  <a:srgbClr val="545E63"/>
                 </a:solidFill>
                 <a:latin typeface="Calibri"/>
               </a:rPr>
@@ -7382,7 +7404,7 @@
                   </a:txBody>
                   <a:tcPr marT="50800" marB="50800" anchor="ctr">
                     <a:solidFill>
-                      <a:srgbClr val="16213E"/>
+                      <a:srgbClr val="2A363B"/>
                     </a:solidFill>
                   </a:tcPr>
                 </a:tc>
@@ -7404,7 +7426,7 @@
                   </a:txBody>
                   <a:tcPr marT="50800" marB="50800" anchor="ctr">
                     <a:solidFill>
-                      <a:srgbClr val="16213E"/>
+                      <a:srgbClr val="2A363B"/>
                     </a:solidFill>
                   </a:tcPr>
                 </a:tc>
@@ -7418,7 +7440,7 @@
                       <a:r>
                         <a:rPr sz="1200">
                           <a:solidFill>
-                            <a:srgbClr val="222222"/>
+                            <a:srgbClr val="2C3234"/>
                           </a:solidFill>
                           <a:latin typeface="Calibri"/>
                         </a:rPr>
@@ -7440,7 +7462,7 @@
                       <a:r>
                         <a:rPr sz="1200">
                           <a:solidFill>
-                            <a:srgbClr val="222222"/>
+                            <a:srgbClr val="2C3234"/>
                           </a:solidFill>
                           <a:latin typeface="Calibri"/>
                         </a:rPr>
@@ -7464,7 +7486,7 @@
                       <a:r>
                         <a:rPr sz="1200">
                           <a:solidFill>
-                            <a:srgbClr val="222222"/>
+                            <a:srgbClr val="2C3234"/>
                           </a:solidFill>
                           <a:latin typeface="Calibri"/>
                         </a:rPr>
@@ -7474,7 +7496,7 @@
                   </a:txBody>
                   <a:tcPr marT="38100" marB="38100" marL="76200" anchor="ctr">
                     <a:solidFill>
-                      <a:srgbClr val="F6F7F9"/>
+                      <a:srgbClr val="F6F7F7"/>
                     </a:solidFill>
                   </a:tcPr>
                 </a:tc>
@@ -7486,7 +7508,7 @@
                       <a:r>
                         <a:rPr sz="1200">
                           <a:solidFill>
-                            <a:srgbClr val="222222"/>
+                            <a:srgbClr val="2C3234"/>
                           </a:solidFill>
                           <a:latin typeface="Calibri"/>
                         </a:rPr>
@@ -7496,7 +7518,7 @@
                   </a:txBody>
                   <a:tcPr marT="38100" marB="38100" marL="76200" anchor="ctr">
                     <a:solidFill>
-                      <a:srgbClr val="F6F7F9"/>
+                      <a:srgbClr val="F6F7F7"/>
                     </a:solidFill>
                   </a:tcPr>
                 </a:tc>
@@ -7510,7 +7532,7 @@
                       <a:r>
                         <a:rPr sz="1200">
                           <a:solidFill>
-                            <a:srgbClr val="222222"/>
+                            <a:srgbClr val="2C3234"/>
                           </a:solidFill>
                           <a:latin typeface="Calibri"/>
                         </a:rPr>
@@ -7532,7 +7554,7 @@
                       <a:r>
                         <a:rPr sz="1200">
                           <a:solidFill>
-                            <a:srgbClr val="222222"/>
+                            <a:srgbClr val="2C3234"/>
                           </a:solidFill>
                           <a:latin typeface="Calibri"/>
                         </a:rPr>
@@ -7556,7 +7578,7 @@
                       <a:r>
                         <a:rPr sz="1200">
                           <a:solidFill>
-                            <a:srgbClr val="222222"/>
+                            <a:srgbClr val="2C3234"/>
                           </a:solidFill>
                           <a:latin typeface="Calibri"/>
                         </a:rPr>
@@ -7566,7 +7588,7 @@
                   </a:txBody>
                   <a:tcPr marT="38100" marB="38100" marL="76200" anchor="ctr">
                     <a:solidFill>
-                      <a:srgbClr val="F6F7F9"/>
+                      <a:srgbClr val="F6F7F7"/>
                     </a:solidFill>
                   </a:tcPr>
                 </a:tc>
@@ -7578,7 +7600,7 @@
                       <a:r>
                         <a:rPr sz="1200">
                           <a:solidFill>
-                            <a:srgbClr val="222222"/>
+                            <a:srgbClr val="2C3234"/>
                           </a:solidFill>
                           <a:latin typeface="Calibri"/>
                         </a:rPr>
@@ -7588,7 +7610,7 @@
                   </a:txBody>
                   <a:tcPr marT="38100" marB="38100" marL="76200" anchor="ctr">
                     <a:solidFill>
-                      <a:srgbClr val="F6F7F9"/>
+                      <a:srgbClr val="F6F7F7"/>
                     </a:solidFill>
                   </a:tcPr>
                 </a:tc>
@@ -7627,7 +7649,7 @@
             <a:r>
               <a:rPr sz="1250" b="0" i="1">
                 <a:solidFill>
-                  <a:srgbClr val="16213E"/>
+                  <a:srgbClr val="2A363B"/>
                 </a:solidFill>
                 <a:latin typeface="Calibri"/>
               </a:rPr>
@@ -7692,7 +7714,7 @@
             <a:r>
               <a:rPr sz="1150" b="1" i="0">
                 <a:solidFill>
-                  <a:srgbClr val="1F9E97"/>
+                  <a:srgbClr val="5FA8CC"/>
                 </a:solidFill>
                 <a:latin typeface="Calibri"/>
               </a:rPr>
@@ -7731,7 +7753,7 @@
             <a:r>
               <a:rPr sz="2600" b="1" i="0">
                 <a:solidFill>
-                  <a:srgbClr val="16213E"/>
+                  <a:srgbClr val="2A363B"/>
                 </a:solidFill>
                 <a:latin typeface="Calibri"/>
               </a:rPr>
@@ -7770,7 +7792,7 @@
             <a:r>
               <a:rPr sz="900" b="0" i="0">
                 <a:solidFill>
-                  <a:srgbClr val="8592A6"/>
+                  <a:srgbClr val="8A97A0"/>
                 </a:solidFill>
                 <a:latin typeface="Calibri"/>
               </a:rPr>
@@ -7809,7 +7831,7 @@
             <a:r>
               <a:rPr sz="900" b="0" i="0">
                 <a:solidFill>
-                  <a:srgbClr val="8592A6"/>
+                  <a:srgbClr val="8A97A0"/>
                 </a:solidFill>
                 <a:latin typeface="Calibri"/>
               </a:rPr>
@@ -7848,7 +7870,7 @@
             <a:r>
               <a:rPr sz="1350" b="0" i="0">
                 <a:solidFill>
-                  <a:srgbClr val="3E5C76"/>
+                  <a:srgbClr val="545E63"/>
                 </a:solidFill>
                 <a:latin typeface="Calibri"/>
               </a:rPr>
@@ -7886,13 +7908,13 @@
               <a:spcAft>
                 <a:spcPts val="1000"/>
               </a:spcAft>
-              <a:buFont typeface="Arial"/>
+              <a:buFont typeface="Poppins"/>
               <a:buChar char="•"/>
             </a:pPr>
             <a:r>
               <a:rPr b="1" sz="1350">
                 <a:solidFill>
-                  <a:srgbClr val="222222"/>
+                  <a:srgbClr val="2C3234"/>
                 </a:solidFill>
                 <a:latin typeface="Calibri"/>
               </a:rPr>
@@ -7901,7 +7923,7 @@
             <a:r>
               <a:rPr sz="1350">
                 <a:solidFill>
-                  <a:srgbClr val="222222"/>
+                  <a:srgbClr val="2C3234"/>
                 </a:solidFill>
                 <a:latin typeface="Calibri"/>
               </a:rPr>
@@ -7916,13 +7938,13 @@
               <a:spcAft>
                 <a:spcPts val="1000"/>
               </a:spcAft>
-              <a:buFont typeface="Arial"/>
+              <a:buFont typeface="Poppins"/>
               <a:buChar char="•"/>
             </a:pPr>
             <a:r>
               <a:rPr b="1" sz="1350">
                 <a:solidFill>
-                  <a:srgbClr val="222222"/>
+                  <a:srgbClr val="2C3234"/>
                 </a:solidFill>
                 <a:latin typeface="Calibri"/>
               </a:rPr>
@@ -7931,7 +7953,7 @@
             <a:r>
               <a:rPr sz="1350">
                 <a:solidFill>
-                  <a:srgbClr val="222222"/>
+                  <a:srgbClr val="2C3234"/>
                 </a:solidFill>
                 <a:latin typeface="Calibri"/>
               </a:rPr>
@@ -7946,13 +7968,13 @@
               <a:spcAft>
                 <a:spcPts val="1000"/>
               </a:spcAft>
-              <a:buFont typeface="Arial"/>
+              <a:buFont typeface="Poppins"/>
               <a:buChar char="•"/>
             </a:pPr>
             <a:r>
               <a:rPr b="1" sz="1350">
                 <a:solidFill>
-                  <a:srgbClr val="222222"/>
+                  <a:srgbClr val="2C3234"/>
                 </a:solidFill>
                 <a:latin typeface="Calibri"/>
               </a:rPr>
@@ -7961,7 +7983,7 @@
             <a:r>
               <a:rPr sz="1350">
                 <a:solidFill>
-                  <a:srgbClr val="222222"/>
+                  <a:srgbClr val="2C3234"/>
                 </a:solidFill>
                 <a:latin typeface="Calibri"/>
               </a:rPr>
@@ -7987,7 +8009,7 @@
             </a:avLst>
           </a:prstGeom>
           <a:solidFill>
-            <a:srgbClr val="16213E"/>
+            <a:srgbClr val="2A363B"/>
           </a:solidFill>
           <a:ln>
             <a:noFill/>
@@ -7995,7 +8017,7 @@
           <a:effectLst/>
           <a:effectLst>
             <a:outerShdw blurRad="90000" dist="30000" dir="5400000" rotWithShape="0">
-              <a:srgbClr val="16213E">
+              <a:srgbClr val="2A363B">
                 <a:alpha val="20000"/>
               </a:srgbClr>
             </a:outerShdw>
@@ -8053,7 +8075,7 @@
             <a:r>
               <a:rPr sz="1100" b="1" i="0">
                 <a:solidFill>
-                  <a:srgbClr val="1F9E97"/>
+                  <a:srgbClr val="5FA8CC"/>
                 </a:solidFill>
                 <a:latin typeface="Calibri"/>
               </a:rPr>
@@ -8228,7 +8250,7 @@
             <a:r>
               <a:rPr sz="1150" b="1" i="0">
                 <a:solidFill>
-                  <a:srgbClr val="1F9E97"/>
+                  <a:srgbClr val="5FA8CC"/>
                 </a:solidFill>
                 <a:latin typeface="Calibri"/>
               </a:rPr>
@@ -8267,7 +8289,7 @@
             <a:r>
               <a:rPr sz="2600" b="1" i="0">
                 <a:solidFill>
-                  <a:srgbClr val="16213E"/>
+                  <a:srgbClr val="2A363B"/>
                 </a:solidFill>
                 <a:latin typeface="Calibri"/>
               </a:rPr>
@@ -8306,7 +8328,7 @@
             <a:r>
               <a:rPr sz="900" b="0" i="0">
                 <a:solidFill>
-                  <a:srgbClr val="8592A6"/>
+                  <a:srgbClr val="8A97A0"/>
                 </a:solidFill>
                 <a:latin typeface="Calibri"/>
               </a:rPr>
@@ -8345,7 +8367,7 @@
             <a:r>
               <a:rPr sz="900" b="0" i="0">
                 <a:solidFill>
-                  <a:srgbClr val="8592A6"/>
+                  <a:srgbClr val="8A97A0"/>
                 </a:solidFill>
                 <a:latin typeface="Calibri"/>
               </a:rPr>
@@ -8371,7 +8393,7 @@
             </a:avLst>
           </a:prstGeom>
           <a:solidFill>
-            <a:srgbClr val="F6F7F9"/>
+            <a:srgbClr val="F6F7F7"/>
           </a:solidFill>
           <a:ln>
             <a:noFill/>
@@ -8379,7 +8401,7 @@
           <a:effectLst/>
           <a:effectLst>
             <a:outerShdw blurRad="90000" dist="30000" dir="5400000" rotWithShape="0">
-              <a:srgbClr val="16213E">
+              <a:srgbClr val="2A363B">
                 <a:alpha val="20000"/>
               </a:srgbClr>
             </a:outerShdw>
@@ -8422,7 +8444,7 @@
             <a:avLst/>
           </a:prstGeom>
           <a:solidFill>
-            <a:srgbClr val="1F9E97"/>
+            <a:srgbClr val="5FA8CC"/>
           </a:solidFill>
           <a:ln>
             <a:noFill/>
@@ -8481,7 +8503,7 @@
             <a:r>
               <a:rPr sz="1400" b="1" i="0">
                 <a:solidFill>
-                  <a:srgbClr val="16213E"/>
+                  <a:srgbClr val="2A363B"/>
                 </a:solidFill>
                 <a:latin typeface="Calibri"/>
               </a:rPr>
@@ -8520,7 +8542,7 @@
             <a:r>
               <a:rPr sz="1250" b="0" i="0">
                 <a:solidFill>
-                  <a:srgbClr val="3E5C76"/>
+                  <a:srgbClr val="545E63"/>
                 </a:solidFill>
                 <a:latin typeface="Calibri"/>
               </a:rPr>
@@ -8546,7 +8568,7 @@
             </a:avLst>
           </a:prstGeom>
           <a:solidFill>
-            <a:srgbClr val="F6F7F9"/>
+            <a:srgbClr val="F6F7F7"/>
           </a:solidFill>
           <a:ln>
             <a:noFill/>
@@ -8554,7 +8576,7 @@
           <a:effectLst/>
           <a:effectLst>
             <a:outerShdw blurRad="90000" dist="30000" dir="5400000" rotWithShape="0">
-              <a:srgbClr val="16213E">
+              <a:srgbClr val="2A363B">
                 <a:alpha val="20000"/>
               </a:srgbClr>
             </a:outerShdw>
@@ -8597,7 +8619,7 @@
             <a:avLst/>
           </a:prstGeom>
           <a:solidFill>
-            <a:srgbClr val="E0982A"/>
+            <a:srgbClr val="E3A253"/>
           </a:solidFill>
           <a:ln>
             <a:noFill/>
@@ -8656,7 +8678,7 @@
             <a:r>
               <a:rPr sz="1400" b="1" i="0">
                 <a:solidFill>
-                  <a:srgbClr val="16213E"/>
+                  <a:srgbClr val="2A363B"/>
                 </a:solidFill>
                 <a:latin typeface="Calibri"/>
               </a:rPr>
@@ -8695,7 +8717,7 @@
             <a:r>
               <a:rPr sz="1250" b="0" i="0">
                 <a:solidFill>
-                  <a:srgbClr val="3E5C76"/>
+                  <a:srgbClr val="545E63"/>
                 </a:solidFill>
                 <a:latin typeface="Calibri"/>
               </a:rPr>
@@ -8721,7 +8743,7 @@
             </a:avLst>
           </a:prstGeom>
           <a:solidFill>
-            <a:srgbClr val="F6F7F9"/>
+            <a:srgbClr val="F6F7F7"/>
           </a:solidFill>
           <a:ln>
             <a:noFill/>
@@ -8729,7 +8751,7 @@
           <a:effectLst/>
           <a:effectLst>
             <a:outerShdw blurRad="90000" dist="30000" dir="5400000" rotWithShape="0">
-              <a:srgbClr val="16213E">
+              <a:srgbClr val="2A363B">
                 <a:alpha val="20000"/>
               </a:srgbClr>
             </a:outerShdw>
@@ -8772,7 +8794,7 @@
             <a:avLst/>
           </a:prstGeom>
           <a:solidFill>
-            <a:srgbClr val="C0392B"/>
+            <a:srgbClr val="A02E2E"/>
           </a:solidFill>
           <a:ln>
             <a:noFill/>
@@ -8831,7 +8853,7 @@
             <a:r>
               <a:rPr sz="1400" b="1" i="0">
                 <a:solidFill>
-                  <a:srgbClr val="16213E"/>
+                  <a:srgbClr val="2A363B"/>
                 </a:solidFill>
                 <a:latin typeface="Calibri"/>
               </a:rPr>
@@ -8870,7 +8892,7 @@
             <a:r>
               <a:rPr sz="1250" b="0" i="0">
                 <a:solidFill>
-                  <a:srgbClr val="3E5C76"/>
+                  <a:srgbClr val="545E63"/>
                 </a:solidFill>
                 <a:latin typeface="Calibri"/>
               </a:rPr>
@@ -8909,7 +8931,7 @@
             <a:r>
               <a:rPr sz="1300" b="0" i="1">
                 <a:solidFill>
-                  <a:srgbClr val="16213E"/>
+                  <a:srgbClr val="2A363B"/>
                 </a:solidFill>
                 <a:latin typeface="Calibri"/>
               </a:rPr>
@@ -8974,7 +8996,7 @@
             <a:r>
               <a:rPr sz="1150" b="1" i="0">
                 <a:solidFill>
-                  <a:srgbClr val="1F9E97"/>
+                  <a:srgbClr val="5FA8CC"/>
                 </a:solidFill>
                 <a:latin typeface="Calibri"/>
               </a:rPr>
@@ -9013,7 +9035,7 @@
             <a:r>
               <a:rPr sz="2600" b="1" i="0">
                 <a:solidFill>
-                  <a:srgbClr val="16213E"/>
+                  <a:srgbClr val="2A363B"/>
                 </a:solidFill>
                 <a:latin typeface="Calibri"/>
               </a:rPr>
@@ -9052,7 +9074,7 @@
             <a:r>
               <a:rPr sz="900" b="0" i="0">
                 <a:solidFill>
-                  <a:srgbClr val="8592A6"/>
+                  <a:srgbClr val="8A97A0"/>
                 </a:solidFill>
                 <a:latin typeface="Calibri"/>
               </a:rPr>
@@ -9091,7 +9113,7 @@
             <a:r>
               <a:rPr sz="900" b="0" i="0">
                 <a:solidFill>
-                  <a:srgbClr val="8592A6"/>
+                  <a:srgbClr val="8A97A0"/>
                 </a:solidFill>
                 <a:latin typeface="Calibri"/>
               </a:rPr>
@@ -9117,7 +9139,7 @@
             </a:avLst>
           </a:prstGeom>
           <a:solidFill>
-            <a:srgbClr val="F6F7F9"/>
+            <a:srgbClr val="F6F7F7"/>
           </a:solidFill>
           <a:ln>
             <a:noFill/>
@@ -9125,7 +9147,7 @@
           <a:effectLst/>
           <a:effectLst>
             <a:outerShdw blurRad="90000" dist="30000" dir="5400000" rotWithShape="0">
-              <a:srgbClr val="16213E">
+              <a:srgbClr val="2A363B">
                 <a:alpha val="20000"/>
               </a:srgbClr>
             </a:outerShdw>
@@ -9168,7 +9190,7 @@
             <a:avLst/>
           </a:prstGeom>
           <a:solidFill>
-            <a:srgbClr val="1F9E97"/>
+            <a:srgbClr val="5FA8CC"/>
           </a:solidFill>
           <a:ln>
             <a:noFill/>
@@ -9227,7 +9249,7 @@
             <a:r>
               <a:rPr sz="3400" b="1" i="0">
                 <a:solidFill>
-                  <a:srgbClr val="16213E"/>
+                  <a:srgbClr val="2A363B"/>
                 </a:solidFill>
                 <a:latin typeface="Calibri"/>
               </a:rPr>
@@ -9266,7 +9288,7 @@
             <a:r>
               <a:rPr sz="1100" b="0" i="0">
                 <a:solidFill>
-                  <a:srgbClr val="3E5C76"/>
+                  <a:srgbClr val="545E63"/>
                 </a:solidFill>
                 <a:latin typeface="Calibri"/>
               </a:rPr>
@@ -9292,7 +9314,7 @@
             </a:avLst>
           </a:prstGeom>
           <a:solidFill>
-            <a:srgbClr val="F6F7F9"/>
+            <a:srgbClr val="F6F7F7"/>
           </a:solidFill>
           <a:ln>
             <a:noFill/>
@@ -9300,7 +9322,7 @@
           <a:effectLst/>
           <a:effectLst>
             <a:outerShdw blurRad="90000" dist="30000" dir="5400000" rotWithShape="0">
-              <a:srgbClr val="16213E">
+              <a:srgbClr val="2A363B">
                 <a:alpha val="20000"/>
               </a:srgbClr>
             </a:outerShdw>
@@ -9343,7 +9365,7 @@
             <a:avLst/>
           </a:prstGeom>
           <a:solidFill>
-            <a:srgbClr val="1F9E97"/>
+            <a:srgbClr val="5FA8CC"/>
           </a:solidFill>
           <a:ln>
             <a:noFill/>
@@ -9402,7 +9424,7 @@
             <a:r>
               <a:rPr sz="3400" b="1" i="0">
                 <a:solidFill>
-                  <a:srgbClr val="16213E"/>
+                  <a:srgbClr val="2A363B"/>
                 </a:solidFill>
                 <a:latin typeface="Calibri"/>
               </a:rPr>
@@ -9441,7 +9463,7 @@
             <a:r>
               <a:rPr sz="1100" b="0" i="0">
                 <a:solidFill>
-                  <a:srgbClr val="3E5C76"/>
+                  <a:srgbClr val="545E63"/>
                 </a:solidFill>
                 <a:latin typeface="Calibri"/>
               </a:rPr>
@@ -9467,7 +9489,7 @@
             </a:avLst>
           </a:prstGeom>
           <a:solidFill>
-            <a:srgbClr val="F6F7F9"/>
+            <a:srgbClr val="F6F7F7"/>
           </a:solidFill>
           <a:ln>
             <a:noFill/>
@@ -9475,7 +9497,7 @@
           <a:effectLst/>
           <a:effectLst>
             <a:outerShdw blurRad="90000" dist="30000" dir="5400000" rotWithShape="0">
-              <a:srgbClr val="16213E">
+              <a:srgbClr val="2A363B">
                 <a:alpha val="20000"/>
               </a:srgbClr>
             </a:outerShdw>
@@ -9518,7 +9540,7 @@
             <a:avLst/>
           </a:prstGeom>
           <a:solidFill>
-            <a:srgbClr val="E0982A"/>
+            <a:srgbClr val="E3A253"/>
           </a:solidFill>
           <a:ln>
             <a:noFill/>
@@ -9577,7 +9599,7 @@
             <a:r>
               <a:rPr sz="3400" b="1" i="0">
                 <a:solidFill>
-                  <a:srgbClr val="16213E"/>
+                  <a:srgbClr val="2A363B"/>
                 </a:solidFill>
                 <a:latin typeface="Calibri"/>
               </a:rPr>
@@ -9616,7 +9638,7 @@
             <a:r>
               <a:rPr sz="1100" b="0" i="0">
                 <a:solidFill>
-                  <a:srgbClr val="3E5C76"/>
+                  <a:srgbClr val="545E63"/>
                 </a:solidFill>
                 <a:latin typeface="Calibri"/>
               </a:rPr>
@@ -9642,7 +9664,7 @@
             </a:avLst>
           </a:prstGeom>
           <a:solidFill>
-            <a:srgbClr val="F6F7F9"/>
+            <a:srgbClr val="F6F7F7"/>
           </a:solidFill>
           <a:ln>
             <a:noFill/>
@@ -9650,7 +9672,7 @@
           <a:effectLst/>
           <a:effectLst>
             <a:outerShdw blurRad="90000" dist="30000" dir="5400000" rotWithShape="0">
-              <a:srgbClr val="16213E">
+              <a:srgbClr val="2A363B">
                 <a:alpha val="20000"/>
               </a:srgbClr>
             </a:outerShdw>
@@ -9693,7 +9715,7 @@
             <a:avLst/>
           </a:prstGeom>
           <a:solidFill>
-            <a:srgbClr val="E0982A"/>
+            <a:srgbClr val="E3A253"/>
           </a:solidFill>
           <a:ln>
             <a:noFill/>
@@ -9752,7 +9774,7 @@
             <a:r>
               <a:rPr sz="3400" b="1" i="0">
                 <a:solidFill>
-                  <a:srgbClr val="16213E"/>
+                  <a:srgbClr val="2A363B"/>
                 </a:solidFill>
                 <a:latin typeface="Calibri"/>
               </a:rPr>
@@ -9791,7 +9813,7 @@
             <a:r>
               <a:rPr sz="1100" b="0" i="0">
                 <a:solidFill>
-                  <a:srgbClr val="3E5C76"/>
+                  <a:srgbClr val="545E63"/>
                 </a:solidFill>
                 <a:latin typeface="Calibri"/>
               </a:rPr>
@@ -9817,7 +9839,7 @@
             </a:avLst>
           </a:prstGeom>
           <a:solidFill>
-            <a:srgbClr val="F6F7F9"/>
+            <a:srgbClr val="F6F7F7"/>
           </a:solidFill>
           <a:ln>
             <a:noFill/>
@@ -9825,7 +9847,7 @@
           <a:effectLst/>
           <a:effectLst>
             <a:outerShdw blurRad="90000" dist="30000" dir="5400000" rotWithShape="0">
-              <a:srgbClr val="16213E">
+              <a:srgbClr val="2A363B">
                 <a:alpha val="20000"/>
               </a:srgbClr>
             </a:outerShdw>
@@ -9868,7 +9890,7 @@
             <a:avLst/>
           </a:prstGeom>
           <a:solidFill>
-            <a:srgbClr val="2E8B57"/>
+            <a:srgbClr val="2C6644"/>
           </a:solidFill>
           <a:ln>
             <a:noFill/>
@@ -9927,7 +9949,7 @@
             <a:r>
               <a:rPr sz="3400" b="1" i="0">
                 <a:solidFill>
-                  <a:srgbClr val="16213E"/>
+                  <a:srgbClr val="2A363B"/>
                 </a:solidFill>
                 <a:latin typeface="Calibri"/>
               </a:rPr>
@@ -9966,7 +9988,7 @@
             <a:r>
               <a:rPr sz="1100" b="0" i="0">
                 <a:solidFill>
-                  <a:srgbClr val="3E5C76"/>
+                  <a:srgbClr val="545E63"/>
                 </a:solidFill>
                 <a:latin typeface="Calibri"/>
               </a:rPr>
@@ -9992,7 +10014,7 @@
             </a:avLst>
           </a:prstGeom>
           <a:solidFill>
-            <a:srgbClr val="F6F7F9"/>
+            <a:srgbClr val="F6F7F7"/>
           </a:solidFill>
           <a:ln>
             <a:noFill/>
@@ -10000,7 +10022,7 @@
           <a:effectLst/>
           <a:effectLst>
             <a:outerShdw blurRad="90000" dist="30000" dir="5400000" rotWithShape="0">
-              <a:srgbClr val="16213E">
+              <a:srgbClr val="2A363B">
                 <a:alpha val="20000"/>
               </a:srgbClr>
             </a:outerShdw>
@@ -10043,7 +10065,7 @@
             <a:avLst/>
           </a:prstGeom>
           <a:solidFill>
-            <a:srgbClr val="C0392B"/>
+            <a:srgbClr val="A02E2E"/>
           </a:solidFill>
           <a:ln>
             <a:noFill/>
@@ -10102,7 +10124,7 @@
             <a:r>
               <a:rPr sz="3400" b="1" i="0">
                 <a:solidFill>
-                  <a:srgbClr val="16213E"/>
+                  <a:srgbClr val="2A363B"/>
                 </a:solidFill>
                 <a:latin typeface="Calibri"/>
               </a:rPr>
@@ -10141,7 +10163,7 @@
             <a:r>
               <a:rPr sz="1100" b="0" i="0">
                 <a:solidFill>
-                  <a:srgbClr val="3E5C76"/>
+                  <a:srgbClr val="545E63"/>
                 </a:solidFill>
                 <a:latin typeface="Calibri"/>
               </a:rPr>
@@ -10180,7 +10202,7 @@
             <a:r>
               <a:rPr sz="1000" b="0" i="1">
                 <a:solidFill>
-                  <a:srgbClr val="8592A6"/>
+                  <a:srgbClr val="8A97A0"/>
                 </a:solidFill>
                 <a:latin typeface="Calibri"/>
               </a:rPr>
@@ -10203,7 +10225,7 @@
     <p:bg>
       <p:bgPr>
         <a:solidFill>
-          <a:srgbClr val="16213E"/>
+          <a:srgbClr val="2A363B"/>
         </a:solidFill>
         <a:effectLst/>
       </p:bgPr>
@@ -10230,7 +10252,7 @@
             <a:avLst/>
           </a:prstGeom>
           <a:solidFill>
-            <a:srgbClr val="0F3460"/>
+            <a:srgbClr val="3F474A"/>
           </a:solidFill>
           <a:ln>
             <a:noFill/>
@@ -10289,7 +10311,7 @@
             <a:r>
               <a:rPr sz="6400" b="1" i="0">
                 <a:solidFill>
-                  <a:srgbClr val="1F9E97"/>
+                  <a:srgbClr val="5FA8CC"/>
                 </a:solidFill>
                 <a:latin typeface="Calibri"/>
               </a:rPr>
@@ -10367,7 +10389,7 @@
             <a:r>
               <a:rPr sz="1500" b="0" i="1">
                 <a:solidFill>
-                  <a:srgbClr val="C9D6EC"/>
+                  <a:srgbClr val="C7D3D8"/>
                 </a:solidFill>
                 <a:latin typeface="Calibri"/>
               </a:rPr>
@@ -10406,7 +10428,7 @@
             <a:r>
               <a:rPr sz="900" b="0" i="0">
                 <a:solidFill>
-                  <a:srgbClr val="B8C2D6"/>
+                  <a:srgbClr val="B7BEC2"/>
                 </a:solidFill>
                 <a:latin typeface="Calibri"/>
               </a:rPr>
@@ -10471,7 +10493,7 @@
             <a:r>
               <a:rPr sz="1150" b="1" i="0">
                 <a:solidFill>
-                  <a:srgbClr val="1F9E97"/>
+                  <a:srgbClr val="5FA8CC"/>
                 </a:solidFill>
                 <a:latin typeface="Calibri"/>
               </a:rPr>
@@ -10510,7 +10532,7 @@
             <a:r>
               <a:rPr sz="2600" b="1" i="0">
                 <a:solidFill>
-                  <a:srgbClr val="16213E"/>
+                  <a:srgbClr val="2A363B"/>
                 </a:solidFill>
                 <a:latin typeface="Calibri"/>
               </a:rPr>
@@ -10549,7 +10571,7 @@
             <a:r>
               <a:rPr sz="900" b="0" i="0">
                 <a:solidFill>
-                  <a:srgbClr val="8592A6"/>
+                  <a:srgbClr val="8A97A0"/>
                 </a:solidFill>
                 <a:latin typeface="Calibri"/>
               </a:rPr>
@@ -10588,7 +10610,7 @@
             <a:r>
               <a:rPr sz="900" b="0" i="0">
                 <a:solidFill>
-                  <a:srgbClr val="8592A6"/>
+                  <a:srgbClr val="8A97A0"/>
                 </a:solidFill>
                 <a:latin typeface="Calibri"/>
               </a:rPr>
@@ -10664,7 +10686,7 @@
         <a:srgbClr val="F79646"/>
       </a:accent6>
       <a:hlink>
-        <a:srgbClr val="0000FF"/>
+        <a:srgbClr val="2E7DA6"/>
       </a:hlink>
       <a:folHlink>
         <a:srgbClr val="800080"/>
@@ -10714,8 +10736,8 @@
         <a:font script="Hang" typeface="맑은 고딕"/>
         <a:font script="Hans" typeface="宋体"/>
         <a:font script="Hant" typeface="新細明體"/>
-        <a:font script="Arab" typeface="Arial"/>
-        <a:font script="Hebr" typeface="Arial"/>
+        <a:font script="Arab" typeface="Poppins"/>
+        <a:font script="Hebr" typeface="Poppins"/>
         <a:font script="Thai" typeface="Cordia New"/>
         <a:font script="Ethi" typeface="Nyala"/>
         <a:font script="Beng" typeface="Vrinda"/>
@@ -10737,7 +10759,7 @@
         <a:font script="Laoo" typeface="DokChampa"/>
         <a:font script="Sinh" typeface="Iskoola Pota"/>
         <a:font script="Mong" typeface="Mongolian Baiti"/>
-        <a:font script="Viet" typeface="Arial"/>
+        <a:font script="Viet" typeface="Poppins"/>
         <a:font script="Uigh" typeface="Microsoft Uighur"/>
         <a:font script="Geor" typeface="Sylfaen"/>
       </a:minorFont>

</xml_diff>

<commit_message>
Apply Getamazednow AI Design System v1.2 re-skin to training artefacts
- Add project localisation note (Design-System-Localisation.md) recording
  artefact name, version/status and the cover/master choices for v1.2
- Re-skin training deck + Word guide onto the v1.2 presentation and
  whitepaper cover layer; export matching PDFs
- Vendor the cover/background image assets and the logo files the web
  artefacts need into dashboard/assets/
- Keep the design-system source itself unpublished: ignore the v1.2
  folder as v1.0 already was
</commit_message>
<xml_diff>
--- a/training/slides/GenAI-Observability-Exec-Overview.pptx
+++ b/training/slides/GenAI-Observability-Exec-Overview.pptx
@@ -3111,19 +3111,162 @@
         <p:nvPr/>
       </p:nvGrpSpPr>
       <p:grpSpPr/>
-      <p:sp>
-        <p:nvSpPr>
-          <p:cNvPr id="2" name="Oval 1"/>
+      <p:pic>
+        <p:nvPicPr>
+          <p:cNvPr id="901" name="Picture 900" descr="GenAIObsPPT-2.jpg"/>
+          <p:cNvPicPr>
+            <a:picLocks noChangeAspect="1"/>
+          </p:cNvPicPr>
+          <p:nvPr/>
+        </p:nvPicPr>
+        <p:blipFill>
+          <a:blip r:embed="rId3"/>
+          <a:stretch>
+            <a:fillRect/>
+          </a:stretch>
+        </p:blipFill>
+        <p:spPr>
+          <a:xfrm>
+            <a:off x="0" y="0"/>
+            <a:ext cx="12191695" cy="6858000"/>
+          </a:xfrm>
+          <a:prstGeom prst="rect">
+            <a:avLst/>
+          </a:prstGeom>
+        </p:spPr>
+      </p:pic>
+      <p:sp>
+        <p:nvSpPr>
+          <p:cNvPr id="4" name="TextBox 3"/>
+          <p:cNvSpPr txBox="1"/>
+          <p:nvPr/>
+        </p:nvSpPr>
+        <p:spPr>
+          <a:xfrm>
+            <a:off x="822960" y="1965960"/>
+            <a:ext cx="8229600" cy="457200"/>
+          </a:xfrm>
+          <a:prstGeom prst="rect">
+            <a:avLst/>
+          </a:prstGeom>
+          <a:noFill/>
+        </p:spPr>
+        <p:txBody>
+          <a:bodyPr wrap="square" lIns="0" rIns="0" tIns="0" bIns="0">
+            <a:spAutoFit/>
+          </a:bodyPr>
+          <a:lstStyle/>
+          <a:p>
+            <a:pPr algn="l">
+              <a:lnSpc>
+                <a:spcPct val="115000"/>
+              </a:lnSpc>
+            </a:pPr>
+            <a:r>
+              <a:rPr sz="1400" b="1" i="0">
+                <a:solidFill>
+                  <a:srgbClr val="5FA8CC"/>
+                </a:solidFill>
+                <a:latin typeface="Calibri"/>
+              </a:rPr>
+              <a:t>MOCK / PORTFOLIO REFERENCE</a:t>
+            </a:r>
+          </a:p>
+        </p:txBody>
+      </p:sp>
+      <p:sp>
+        <p:nvSpPr>
+          <p:cNvPr id="5" name="TextBox 4"/>
+          <p:cNvSpPr txBox="1"/>
+          <p:nvPr/>
+        </p:nvSpPr>
+        <p:spPr>
+          <a:xfrm>
+            <a:off x="822960" y="2377440"/>
+            <a:ext cx="9601200" cy="1554480"/>
+          </a:xfrm>
+          <a:prstGeom prst="rect">
+            <a:avLst/>
+          </a:prstGeom>
+          <a:noFill/>
+        </p:spPr>
+        <p:txBody>
+          <a:bodyPr wrap="square" lIns="0" rIns="0" tIns="0" bIns="0">
+            <a:spAutoFit/>
+          </a:bodyPr>
+          <a:lstStyle/>
+          <a:p>
+            <a:pPr algn="l">
+              <a:lnSpc>
+                <a:spcPct val="105000"/>
+              </a:lnSpc>
+            </a:pPr>
+            <a:r>
+              <a:rPr sz="4000" b="1" i="0">
+                <a:solidFill>
+                  <a:srgbClr val="FFFFFF"/>
+                </a:solidFill>
+                <a:latin typeface="Calibri"/>
+              </a:rPr>
+              <a:t>GenAI Project Observability</a:t>
+            </a:r>
+          </a:p>
+        </p:txBody>
+      </p:sp>
+      <p:sp>
+        <p:nvSpPr>
+          <p:cNvPr id="6" name="TextBox 5"/>
+          <p:cNvSpPr txBox="1"/>
+          <p:nvPr/>
+        </p:nvSpPr>
+        <p:spPr>
+          <a:xfrm>
+            <a:off x="822960" y="3794760"/>
+            <a:ext cx="8412480" cy="1097280"/>
+          </a:xfrm>
+          <a:prstGeom prst="rect">
+            <a:avLst/>
+          </a:prstGeom>
+          <a:noFill/>
+        </p:spPr>
+        <p:txBody>
+          <a:bodyPr wrap="square" lIns="0" rIns="0" tIns="0" bIns="0">
+            <a:spAutoFit/>
+          </a:bodyPr>
+          <a:lstStyle/>
+          <a:p>
+            <a:pPr algn="l">
+              <a:lnSpc>
+                <a:spcPct val="130000"/>
+              </a:lnSpc>
+            </a:pPr>
+            <a:r>
+              <a:rPr sz="1600" b="0" i="1">
+                <a:solidFill>
+                  <a:srgbClr val="C7D3D8"/>
+                </a:solidFill>
+                <a:latin typeface="Calibri"/>
+              </a:rPr>
+              <a:t>A reference architecture and demo dashboard for observing agentic Gen AI workflows in production — built for architecture-board, risk-committee and Community of Practice review ahead of a real Datadog implementation.</a:t>
+            </a:r>
+          </a:p>
+        </p:txBody>
+      </p:sp>
+      <p:sp>
+        <p:nvSpPr>
+          <p:cNvPr id="7" name="Rounded Rectangle 6"/>
           <p:cNvSpPr/>
           <p:nvPr/>
         </p:nvSpPr>
         <p:spPr>
           <a:xfrm>
-            <a:off x="8869680" y="-2103120"/>
-            <a:ext cx="5943600" cy="5943600"/>
-          </a:xfrm>
-          <a:prstGeom prst="ellipse">
-            <a:avLst/>
+            <a:off x="822960" y="5074920"/>
+            <a:ext cx="3931920" cy="457200"/>
+          </a:xfrm>
+          <a:prstGeom prst="roundRect">
+            <a:avLst>
+              <a:gd name="adj" fmla="val 50000"/>
+            </a:avLst>
           </a:prstGeom>
           <a:solidFill>
             <a:srgbClr val="3F474A"/>
@@ -3157,169 +3300,8 @@
       </p:sp>
       <p:sp>
         <p:nvSpPr>
-          <p:cNvPr id="3" name="Oval 2"/>
-          <p:cNvSpPr/>
-          <p:nvPr/>
-        </p:nvSpPr>
-        <p:spPr>
-          <a:xfrm>
-            <a:off x="9966960" y="3108960"/>
-            <a:ext cx="3291840" cy="3291840"/>
-          </a:xfrm>
-          <a:prstGeom prst="ellipse">
-            <a:avLst/>
-          </a:prstGeom>
-          <a:solidFill>
-            <a:srgbClr val="5FA8CC"/>
-          </a:solidFill>
-          <a:ln>
-            <a:noFill/>
-          </a:ln>
-          <a:effectLst/>
-        </p:spPr>
-        <p:style>
-          <a:lnRef idx="1">
-            <a:schemeClr val="accent1"/>
-          </a:lnRef>
-          <a:fillRef idx="3">
-            <a:schemeClr val="accent1"/>
-          </a:fillRef>
-          <a:effectRef idx="2">
-            <a:schemeClr val="accent1"/>
-          </a:effectRef>
-          <a:fontRef idx="minor">
-            <a:schemeClr val="lt1"/>
-          </a:fontRef>
-        </p:style>
-        <p:txBody>
-          <a:bodyPr rtlCol="0" anchor="ctr"/>
-          <a:lstStyle/>
-          <a:p>
-            <a:pPr algn="ctr"/>
-          </a:p>
-        </p:txBody>
-      </p:sp>
-      <p:sp>
-        <p:nvSpPr>
-          <p:cNvPr id="4" name="TextBox 3"/>
-          <p:cNvSpPr txBox="1"/>
-          <p:nvPr/>
-        </p:nvSpPr>
-        <p:spPr>
-          <a:xfrm>
-            <a:off x="822960" y="1965960"/>
-            <a:ext cx="8229600" cy="457200"/>
-          </a:xfrm>
-          <a:prstGeom prst="rect">
-            <a:avLst/>
-          </a:prstGeom>
-          <a:noFill/>
-        </p:spPr>
-        <p:txBody>
-          <a:bodyPr wrap="square" lIns="0" rIns="0" tIns="0" bIns="0">
-            <a:spAutoFit/>
-          </a:bodyPr>
-          <a:lstStyle/>
-          <a:p>
-            <a:pPr algn="l">
-              <a:lnSpc>
-                <a:spcPct val="115000"/>
-              </a:lnSpc>
-            </a:pPr>
-            <a:r>
-              <a:rPr sz="1400" b="1" i="0">
-                <a:solidFill>
-                  <a:srgbClr val="5FA8CC"/>
-                </a:solidFill>
-                <a:latin typeface="Calibri"/>
-              </a:rPr>
-              <a:t>MOCK / PORTFOLIO REFERENCE</a:t>
-            </a:r>
-          </a:p>
-        </p:txBody>
-      </p:sp>
-      <p:sp>
-        <p:nvSpPr>
-          <p:cNvPr id="5" name="TextBox 4"/>
-          <p:cNvSpPr txBox="1"/>
-          <p:nvPr/>
-        </p:nvSpPr>
-        <p:spPr>
-          <a:xfrm>
-            <a:off x="822960" y="2377440"/>
-            <a:ext cx="9601200" cy="1554480"/>
-          </a:xfrm>
-          <a:prstGeom prst="rect">
-            <a:avLst/>
-          </a:prstGeom>
-          <a:noFill/>
-        </p:spPr>
-        <p:txBody>
-          <a:bodyPr wrap="square" lIns="0" rIns="0" tIns="0" bIns="0">
-            <a:spAutoFit/>
-          </a:bodyPr>
-          <a:lstStyle/>
-          <a:p>
-            <a:pPr algn="l">
-              <a:lnSpc>
-                <a:spcPct val="105000"/>
-              </a:lnSpc>
-            </a:pPr>
-            <a:r>
-              <a:rPr sz="4000" b="1" i="0">
-                <a:solidFill>
-                  <a:srgbClr val="FFFFFF"/>
-                </a:solidFill>
-                <a:latin typeface="Calibri"/>
-              </a:rPr>
-              <a:t>GenAI Project Observability</a:t>
-            </a:r>
-          </a:p>
-        </p:txBody>
-      </p:sp>
-      <p:sp>
-        <p:nvSpPr>
-          <p:cNvPr id="6" name="TextBox 5"/>
-          <p:cNvSpPr txBox="1"/>
-          <p:nvPr/>
-        </p:nvSpPr>
-        <p:spPr>
-          <a:xfrm>
-            <a:off x="822960" y="3794760"/>
-            <a:ext cx="8412480" cy="1097280"/>
-          </a:xfrm>
-          <a:prstGeom prst="rect">
-            <a:avLst/>
-          </a:prstGeom>
-          <a:noFill/>
-        </p:spPr>
-        <p:txBody>
-          <a:bodyPr wrap="square" lIns="0" rIns="0" tIns="0" bIns="0">
-            <a:spAutoFit/>
-          </a:bodyPr>
-          <a:lstStyle/>
-          <a:p>
-            <a:pPr algn="l">
-              <a:lnSpc>
-                <a:spcPct val="130000"/>
-              </a:lnSpc>
-            </a:pPr>
-            <a:r>
-              <a:rPr sz="1600" b="0" i="1">
-                <a:solidFill>
-                  <a:srgbClr val="C7D3D8"/>
-                </a:solidFill>
-                <a:latin typeface="Calibri"/>
-              </a:rPr>
-              <a:t>A reference architecture and demo dashboard for observing agentic Gen AI workflows in production — built for architecture-board, risk-committee and Community of Practice review ahead of a real Datadog implementation.</a:t>
-            </a:r>
-          </a:p>
-        </p:txBody>
-      </p:sp>
-      <p:sp>
-        <p:nvSpPr>
-          <p:cNvPr id="7" name="Rounded Rectangle 6"/>
-          <p:cNvSpPr/>
+          <p:cNvPr id="8" name="TextBox 7"/>
+          <p:cNvSpPr txBox="1"/>
           <p:nvPr/>
         </p:nvSpPr>
         <p:spPr>
@@ -3327,52 +3309,6 @@
             <a:off x="822960" y="5074920"/>
             <a:ext cx="3931920" cy="457200"/>
           </a:xfrm>
-          <a:prstGeom prst="roundRect">
-            <a:avLst>
-              <a:gd name="adj" fmla="val 50000"/>
-            </a:avLst>
-          </a:prstGeom>
-          <a:solidFill>
-            <a:srgbClr val="3F474A"/>
-          </a:solidFill>
-          <a:ln>
-            <a:noFill/>
-          </a:ln>
-          <a:effectLst/>
-        </p:spPr>
-        <p:style>
-          <a:lnRef idx="1">
-            <a:schemeClr val="accent1"/>
-          </a:lnRef>
-          <a:fillRef idx="3">
-            <a:schemeClr val="accent1"/>
-          </a:fillRef>
-          <a:effectRef idx="2">
-            <a:schemeClr val="accent1"/>
-          </a:effectRef>
-          <a:fontRef idx="minor">
-            <a:schemeClr val="lt1"/>
-          </a:fontRef>
-        </p:style>
-        <p:txBody>
-          <a:bodyPr rtlCol="0" anchor="ctr"/>
-          <a:lstStyle/>
-          <a:p>
-            <a:pPr algn="ctr"/>
-          </a:p>
-        </p:txBody>
-      </p:sp>
-      <p:sp>
-        <p:nvSpPr>
-          <p:cNvPr id="8" name="TextBox 7"/>
-          <p:cNvSpPr txBox="1"/>
-          <p:nvPr/>
-        </p:nvSpPr>
-        <p:spPr>
-          <a:xfrm>
-            <a:off x="822960" y="5074920"/>
-            <a:ext cx="3931920" cy="457200"/>
-          </a:xfrm>
           <a:prstGeom prst="rect">
             <a:avLst/>
           </a:prstGeom>
@@ -3442,26 +3378,98 @@
       </p:sp>
       <p:pic>
         <p:nvPicPr>
-          <p:cNvPr id="900" name="Getamazednow AI badge"/>
-          <p:cNvPicPr/>
+          <p:cNvPr id="902" name="Picture 901" descr="keyline_signal.png"/>
+          <p:cNvPicPr>
+            <a:picLocks noChangeAspect="1"/>
+          </p:cNvPicPr>
           <p:nvPr/>
         </p:nvPicPr>
         <p:blipFill>
-          <a:blip r:embed="rIdGaiLogo"/>
+          <a:blip r:embed="rId4"/>
           <a:stretch>
             <a:fillRect/>
           </a:stretch>
         </p:blipFill>
         <p:spPr>
           <a:xfrm>
-            <a:off x="10896295" y="457200"/>
-            <a:ext cx="838200" cy="838200"/>
+            <a:off x="822960" y="457200"/>
+            <a:ext cx="822960" cy="822960"/>
           </a:xfrm>
           <a:prstGeom prst="rect">
             <a:avLst/>
           </a:prstGeom>
         </p:spPr>
       </p:pic>
+      <p:sp>
+        <p:nvSpPr>
+          <p:cNvPr id="903" name="TextBox 902"/>
+          <p:cNvSpPr txBox="1"/>
+          <p:nvPr/>
+        </p:nvSpPr>
+        <p:spPr>
+          <a:xfrm>
+            <a:off x="1847088" y="585216"/>
+            <a:ext cx="5029200" cy="457200"/>
+          </a:xfrm>
+          <a:prstGeom prst="rect">
+            <a:avLst/>
+          </a:prstGeom>
+          <a:noFill/>
+        </p:spPr>
+        <p:txBody>
+          <a:bodyPr wrap="square" anchor="t" lIns="0" rIns="0" tIns="0" bIns="0">
+            <a:spAutoFit/>
+          </a:bodyPr>
+          <a:lstStyle/>
+          <a:p>
+            <a:pPr algn="l"/>
+            <a:r>
+              <a:rPr sz="2100" b="1">
+                <a:solidFill>
+                  <a:srgbClr val="FFFFFF"/>
+                </a:solidFill>
+                <a:latin typeface="Poppins"/>
+              </a:rPr>
+              <a:t>Getamazednow AI</a:t>
+            </a:r>
+          </a:p>
+        </p:txBody>
+      </p:sp>
+      <p:sp>
+        <p:nvSpPr>
+          <p:cNvPr id="904" name="TextBox 903"/>
+          <p:cNvSpPr txBox="1"/>
+          <p:nvPr/>
+        </p:nvSpPr>
+        <p:spPr>
+          <a:xfrm>
+            <a:off x="1847088" y="960120"/>
+            <a:ext cx="5029200" cy="320040"/>
+          </a:xfrm>
+          <a:prstGeom prst="rect">
+            <a:avLst/>
+          </a:prstGeom>
+          <a:noFill/>
+        </p:spPr>
+        <p:txBody>
+          <a:bodyPr wrap="square" anchor="t" lIns="0" rIns="0" tIns="0" bIns="0">
+            <a:spAutoFit/>
+          </a:bodyPr>
+          <a:lstStyle/>
+          <a:p>
+            <a:pPr algn="l"/>
+            <a:r>
+              <a:rPr sz="1100" b="0">
+                <a:solidFill>
+                  <a:srgbClr val="A8A17B"/>
+                </a:solidFill>
+                <a:latin typeface="Inter"/>
+              </a:rPr>
+              <a:t>A Getamazednow Company</a:t>
+            </a:r>
+          </a:p>
+        </p:txBody>
+      </p:sp>
     </p:spTree>
   </p:cSld>
   <p:clrMapOvr>
@@ -3633,6 +3641,15 @@
               </a:lnSpc>
             </a:pPr>
             <a:r>
+              <a:rPr lang="en-US" sz="800" b="1">
+                <a:latin typeface="Poppins"/>
+                <a:solidFill>
+                  <a:srgbClr val="2A363B"/>
+                </a:solidFill>
+              </a:rPr>
+              <a:t>Getamazednow AI  ·  A Getamazednow Company        </a:t>
+            </a:r>
+            <a:r>
               <a:rPr sz="900" b="0" i="0">
                 <a:solidFill>
                   <a:srgbClr val="8A97A0"/>
@@ -4019,6 +4036,30 @@
           </a:p>
         </p:txBody>
       </p:sp>
+      <p:pic>
+        <p:nvPicPr>
+          <p:cNvPr id="11" name="Picture 10" descr="mono_ink.png"/>
+          <p:cNvPicPr>
+            <a:picLocks noChangeAspect="1"/>
+          </p:cNvPicPr>
+          <p:nvPr/>
+        </p:nvPicPr>
+        <p:blipFill>
+          <a:blip r:embed="rId2"/>
+          <a:stretch>
+            <a:fillRect/>
+          </a:stretch>
+        </p:blipFill>
+        <p:spPr>
+          <a:xfrm>
+            <a:off x="201168" y="6528816"/>
+            <a:ext cx="182880" cy="182880"/>
+          </a:xfrm>
+          <a:prstGeom prst="rect">
+            <a:avLst/>
+          </a:prstGeom>
+        </p:spPr>
+      </p:pic>
     </p:spTree>
   </p:cSld>
   <p:clrMapOvr>
@@ -4045,50 +4086,30 @@
         <p:nvPr/>
       </p:nvGrpSpPr>
       <p:grpSpPr/>
-      <p:sp>
-        <p:nvSpPr>
-          <p:cNvPr id="2" name="Oval 1"/>
-          <p:cNvSpPr/>
-          <p:nvPr/>
-        </p:nvSpPr>
-        <p:spPr>
-          <a:xfrm>
-            <a:off x="-2194560" y="3931920"/>
-            <a:ext cx="5486400" cy="5486400"/>
-          </a:xfrm>
-          <a:prstGeom prst="ellipse">
-            <a:avLst/>
-          </a:prstGeom>
-          <a:solidFill>
-            <a:srgbClr val="3F474A"/>
-          </a:solidFill>
-          <a:ln>
-            <a:noFill/>
-          </a:ln>
-          <a:effectLst/>
-        </p:spPr>
-        <p:style>
-          <a:lnRef idx="1">
-            <a:schemeClr val="accent1"/>
-          </a:lnRef>
-          <a:fillRef idx="3">
-            <a:schemeClr val="accent1"/>
-          </a:fillRef>
-          <a:effectRef idx="2">
-            <a:schemeClr val="accent1"/>
-          </a:effectRef>
-          <a:fontRef idx="minor">
-            <a:schemeClr val="lt1"/>
-          </a:fontRef>
-        </p:style>
-        <p:txBody>
-          <a:bodyPr rtlCol="0" anchor="ctr"/>
-          <a:lstStyle/>
-          <a:p>
-            <a:pPr algn="ctr"/>
-          </a:p>
-        </p:txBody>
-      </p:sp>
+      <p:pic>
+        <p:nvPicPr>
+          <p:cNvPr id="7" name="Picture 6" descr="GenAIObsPPT-4.jpg"/>
+          <p:cNvPicPr>
+            <a:picLocks noChangeAspect="1"/>
+          </p:cNvPicPr>
+          <p:nvPr/>
+        </p:nvPicPr>
+        <p:blipFill>
+          <a:blip r:embed="rId2"/>
+          <a:stretch>
+            <a:fillRect/>
+          </a:stretch>
+        </p:blipFill>
+        <p:spPr>
+          <a:xfrm>
+            <a:off x="0" y="0"/>
+            <a:ext cx="12191695" cy="6858000"/>
+          </a:xfrm>
+          <a:prstGeom prst="rect">
+            <a:avLst/>
+          </a:prstGeom>
+        </p:spPr>
+      </p:pic>
       <p:sp>
         <p:nvSpPr>
           <p:cNvPr id="3" name="TextBox 2"/>
@@ -4241,6 +4262,74 @@
                 <a:latin typeface="Calibri"/>
               </a:rPr>
               <a:t>11 / 16</a:t>
+            </a:r>
+          </a:p>
+        </p:txBody>
+      </p:sp>
+      <p:pic>
+        <p:nvPicPr>
+          <p:cNvPr id="8" name="Picture 7" descr="mono_white.png"/>
+          <p:cNvPicPr>
+            <a:picLocks noChangeAspect="1"/>
+          </p:cNvPicPr>
+          <p:nvPr/>
+        </p:nvPicPr>
+        <p:blipFill>
+          <a:blip r:embed="rId3"/>
+          <a:stretch>
+            <a:fillRect/>
+          </a:stretch>
+        </p:blipFill>
+        <p:spPr>
+          <a:xfrm>
+            <a:off x="822960" y="6419088"/>
+            <a:ext cx="201168" cy="201168"/>
+          </a:xfrm>
+          <a:prstGeom prst="rect">
+            <a:avLst/>
+          </a:prstGeom>
+        </p:spPr>
+      </p:pic>
+      <p:sp>
+        <p:nvSpPr>
+          <p:cNvPr id="9" name="TextBox 8"/>
+          <p:cNvSpPr txBox="1"/>
+          <p:nvPr/>
+        </p:nvSpPr>
+        <p:spPr>
+          <a:xfrm>
+            <a:off x="1133856" y="6409944"/>
+            <a:ext cx="5943600" cy="256032"/>
+          </a:xfrm>
+          <a:prstGeom prst="rect">
+            <a:avLst/>
+          </a:prstGeom>
+          <a:noFill/>
+        </p:spPr>
+        <p:txBody>
+          <a:bodyPr wrap="square" anchor="ctr" lIns="0" rIns="0" tIns="0" bIns="0">
+            <a:spAutoFit/>
+          </a:bodyPr>
+          <a:lstStyle/>
+          <a:p>
+            <a:pPr algn="l"/>
+            <a:r>
+              <a:rPr sz="850" b="1">
+                <a:solidFill>
+                  <a:srgbClr val="A8A17B"/>
+                </a:solidFill>
+                <a:latin typeface="Poppins"/>
+              </a:rPr>
+              <a:t>Getamazednow AI</a:t>
+            </a:r>
+            <a:r>
+              <a:rPr sz="850" b="0">
+                <a:solidFill>
+                  <a:srgbClr val="A8A17B"/>
+                </a:solidFill>
+                <a:latin typeface="Inter"/>
+              </a:rPr>
+              <a:t>   ·   A Getamazednow Company</a:t>
             </a:r>
           </a:p>
         </p:txBody>
@@ -4416,6 +4505,15 @@
               </a:lnSpc>
             </a:pPr>
             <a:r>
+              <a:rPr lang="en-US" sz="800" b="1">
+                <a:latin typeface="Poppins"/>
+                <a:solidFill>
+                  <a:srgbClr val="2A363B"/>
+                </a:solidFill>
+              </a:rPr>
+              <a:t>Getamazednow AI  ·  A Getamazednow Company        </a:t>
+            </a:r>
+            <a:r>
               <a:rPr sz="900" b="0" i="0">
                 <a:solidFill>
                   <a:srgbClr val="8A97A0"/>
@@ -4646,6 +4744,30 @@
           </a:p>
         </p:txBody>
       </p:sp>
+      <p:pic>
+        <p:nvPicPr>
+          <p:cNvPr id="10" name="Picture 9" descr="mono_ink.png"/>
+          <p:cNvPicPr>
+            <a:picLocks noChangeAspect="1"/>
+          </p:cNvPicPr>
+          <p:nvPr/>
+        </p:nvPicPr>
+        <p:blipFill>
+          <a:blip r:embed="rId3"/>
+          <a:stretch>
+            <a:fillRect/>
+          </a:stretch>
+        </p:blipFill>
+        <p:spPr>
+          <a:xfrm>
+            <a:off x="201168" y="6528816"/>
+            <a:ext cx="182880" cy="182880"/>
+          </a:xfrm>
+          <a:prstGeom prst="rect">
+            <a:avLst/>
+          </a:prstGeom>
+        </p:spPr>
+      </p:pic>
     </p:spTree>
   </p:cSld>
   <p:clrMapOvr>
@@ -4817,6 +4939,15 @@
               </a:lnSpc>
             </a:pPr>
             <a:r>
+              <a:rPr lang="en-US" sz="800" b="1">
+                <a:latin typeface="Poppins"/>
+                <a:solidFill>
+                  <a:srgbClr val="2A363B"/>
+                </a:solidFill>
+              </a:rPr>
+              <a:t>Getamazednow AI  ·  A Getamazednow Company        </a:t>
+            </a:r>
+            <a:r>
               <a:rPr sz="900" b="0" i="0">
                 <a:solidFill>
                   <a:srgbClr val="8A97A0"/>
@@ -5042,6 +5173,30 @@
           </a:p>
         </p:txBody>
       </p:sp>
+      <p:pic>
+        <p:nvPicPr>
+          <p:cNvPr id="11" name="Picture 10" descr="mono_ink.png"/>
+          <p:cNvPicPr>
+            <a:picLocks noChangeAspect="1"/>
+          </p:cNvPicPr>
+          <p:nvPr/>
+        </p:nvPicPr>
+        <p:blipFill>
+          <a:blip r:embed="rId2"/>
+          <a:stretch>
+            <a:fillRect/>
+          </a:stretch>
+        </p:blipFill>
+        <p:spPr>
+          <a:xfrm>
+            <a:off x="201168" y="6528816"/>
+            <a:ext cx="182880" cy="182880"/>
+          </a:xfrm>
+          <a:prstGeom prst="rect">
+            <a:avLst/>
+          </a:prstGeom>
+        </p:spPr>
+      </p:pic>
     </p:spTree>
   </p:cSld>
   <p:clrMapOvr>
@@ -5068,50 +5223,30 @@
         <p:nvPr/>
       </p:nvGrpSpPr>
       <p:grpSpPr/>
-      <p:sp>
-        <p:nvSpPr>
-          <p:cNvPr id="2" name="Oval 1"/>
-          <p:cNvSpPr/>
-          <p:nvPr/>
-        </p:nvSpPr>
-        <p:spPr>
-          <a:xfrm>
-            <a:off x="-2194560" y="3931920"/>
-            <a:ext cx="5486400" cy="5486400"/>
-          </a:xfrm>
-          <a:prstGeom prst="ellipse">
-            <a:avLst/>
-          </a:prstGeom>
-          <a:solidFill>
-            <a:srgbClr val="3F474A"/>
-          </a:solidFill>
-          <a:ln>
-            <a:noFill/>
-          </a:ln>
-          <a:effectLst/>
-        </p:spPr>
-        <p:style>
-          <a:lnRef idx="1">
-            <a:schemeClr val="accent1"/>
-          </a:lnRef>
-          <a:fillRef idx="3">
-            <a:schemeClr val="accent1"/>
-          </a:fillRef>
-          <a:effectRef idx="2">
-            <a:schemeClr val="accent1"/>
-          </a:effectRef>
-          <a:fontRef idx="minor">
-            <a:schemeClr val="lt1"/>
-          </a:fontRef>
-        </p:style>
-        <p:txBody>
-          <a:bodyPr rtlCol="0" anchor="ctr"/>
-          <a:lstStyle/>
-          <a:p>
-            <a:pPr algn="ctr"/>
-          </a:p>
-        </p:txBody>
-      </p:sp>
+      <p:pic>
+        <p:nvPicPr>
+          <p:cNvPr id="7" name="Picture 6" descr="GenAIObsPPT-4.jpg"/>
+          <p:cNvPicPr>
+            <a:picLocks noChangeAspect="1"/>
+          </p:cNvPicPr>
+          <p:nvPr/>
+        </p:nvPicPr>
+        <p:blipFill>
+          <a:blip r:embed="rId2"/>
+          <a:stretch>
+            <a:fillRect/>
+          </a:stretch>
+        </p:blipFill>
+        <p:spPr>
+          <a:xfrm>
+            <a:off x="0" y="0"/>
+            <a:ext cx="12191695" cy="6858000"/>
+          </a:xfrm>
+          <a:prstGeom prst="rect">
+            <a:avLst/>
+          </a:prstGeom>
+        </p:spPr>
+      </p:pic>
       <p:sp>
         <p:nvSpPr>
           <p:cNvPr id="3" name="TextBox 2"/>
@@ -5264,6 +5399,74 @@
                 <a:latin typeface="Calibri"/>
               </a:rPr>
               <a:t>14 / 16</a:t>
+            </a:r>
+          </a:p>
+        </p:txBody>
+      </p:sp>
+      <p:pic>
+        <p:nvPicPr>
+          <p:cNvPr id="8" name="Picture 7" descr="mono_white.png"/>
+          <p:cNvPicPr>
+            <a:picLocks noChangeAspect="1"/>
+          </p:cNvPicPr>
+          <p:nvPr/>
+        </p:nvPicPr>
+        <p:blipFill>
+          <a:blip r:embed="rId3"/>
+          <a:stretch>
+            <a:fillRect/>
+          </a:stretch>
+        </p:blipFill>
+        <p:spPr>
+          <a:xfrm>
+            <a:off x="822960" y="6419088"/>
+            <a:ext cx="201168" cy="201168"/>
+          </a:xfrm>
+          <a:prstGeom prst="rect">
+            <a:avLst/>
+          </a:prstGeom>
+        </p:spPr>
+      </p:pic>
+      <p:sp>
+        <p:nvSpPr>
+          <p:cNvPr id="9" name="TextBox 8"/>
+          <p:cNvSpPr txBox="1"/>
+          <p:nvPr/>
+        </p:nvSpPr>
+        <p:spPr>
+          <a:xfrm>
+            <a:off x="1133856" y="6409944"/>
+            <a:ext cx="5943600" cy="256032"/>
+          </a:xfrm>
+          <a:prstGeom prst="rect">
+            <a:avLst/>
+          </a:prstGeom>
+          <a:noFill/>
+        </p:spPr>
+        <p:txBody>
+          <a:bodyPr wrap="square" anchor="ctr" lIns="0" rIns="0" tIns="0" bIns="0">
+            <a:spAutoFit/>
+          </a:bodyPr>
+          <a:lstStyle/>
+          <a:p>
+            <a:pPr algn="l"/>
+            <a:r>
+              <a:rPr sz="850" b="1">
+                <a:solidFill>
+                  <a:srgbClr val="A8A17B"/>
+                </a:solidFill>
+                <a:latin typeface="Poppins"/>
+              </a:rPr>
+              <a:t>Getamazednow AI</a:t>
+            </a:r>
+            <a:r>
+              <a:rPr sz="850" b="0">
+                <a:solidFill>
+                  <a:srgbClr val="A8A17B"/>
+                </a:solidFill>
+                <a:latin typeface="Inter"/>
+              </a:rPr>
+              <a:t>   ·   A Getamazednow Company</a:t>
             </a:r>
           </a:p>
         </p:txBody>
@@ -5439,6 +5642,15 @@
               </a:lnSpc>
             </a:pPr>
             <a:r>
+              <a:rPr lang="en-US" sz="800" b="1">
+                <a:latin typeface="Poppins"/>
+                <a:solidFill>
+                  <a:srgbClr val="2A363B"/>
+                </a:solidFill>
+              </a:rPr>
+              <a:t>Getamazednow AI  ·  A Getamazednow Company        </a:t>
+            </a:r>
+            <a:r>
               <a:rPr sz="900" b="0" i="0">
                 <a:solidFill>
                   <a:srgbClr val="8A97A0"/>
@@ -5468,6 +5680,30 @@
           <a:xfrm>
             <a:off x="1594780" y="1417320"/>
             <a:ext cx="8971960" cy="4937760"/>
+          </a:xfrm>
+          <a:prstGeom prst="rect">
+            <a:avLst/>
+          </a:prstGeom>
+        </p:spPr>
+      </p:pic>
+      <p:pic>
+        <p:nvPicPr>
+          <p:cNvPr id="7" name="Picture 6" descr="mono_ink.png"/>
+          <p:cNvPicPr>
+            <a:picLocks noChangeAspect="1"/>
+          </p:cNvPicPr>
+          <p:nvPr/>
+        </p:nvPicPr>
+        <p:blipFill>
+          <a:blip r:embed="rId3"/>
+          <a:stretch>
+            <a:fillRect/>
+          </a:stretch>
+        </p:blipFill>
+        <p:spPr>
+          <a:xfrm>
+            <a:off x="201168" y="6528816"/>
+            <a:ext cx="182880" cy="182880"/>
           </a:xfrm>
           <a:prstGeom prst="rect">
             <a:avLst/>
@@ -5645,6 +5881,15 @@
               </a:lnSpc>
             </a:pPr>
             <a:r>
+              <a:rPr lang="en-US" sz="800" b="1">
+                <a:latin typeface="Poppins"/>
+                <a:solidFill>
+                  <a:srgbClr val="2A363B"/>
+                </a:solidFill>
+              </a:rPr>
+              <a:t>Getamazednow AI  ·  A Getamazednow Company        </a:t>
+            </a:r>
+            <a:r>
               <a:rPr sz="900" b="0" i="0">
                 <a:solidFill>
                   <a:srgbClr val="8A97A0"/>
@@ -6054,6 +6299,30 @@
           </a:p>
         </p:txBody>
       </p:sp>
+      <p:pic>
+        <p:nvPicPr>
+          <p:cNvPr id="12" name="Picture 11" descr="mono_ink.png"/>
+          <p:cNvPicPr>
+            <a:picLocks noChangeAspect="1"/>
+          </p:cNvPicPr>
+          <p:nvPr/>
+        </p:nvPicPr>
+        <p:blipFill>
+          <a:blip r:embed="rId2"/>
+          <a:stretch>
+            <a:fillRect/>
+          </a:stretch>
+        </p:blipFill>
+        <p:spPr>
+          <a:xfrm>
+            <a:off x="201168" y="6528816"/>
+            <a:ext cx="182880" cy="182880"/>
+          </a:xfrm>
+          <a:prstGeom prst="rect">
+            <a:avLst/>
+          </a:prstGeom>
+        </p:spPr>
+      </p:pic>
     </p:spTree>
   </p:cSld>
   <p:clrMapOvr>
@@ -6225,6 +6494,15 @@
               </a:lnSpc>
             </a:pPr>
             <a:r>
+              <a:rPr lang="en-US" sz="800" b="1">
+                <a:latin typeface="Poppins"/>
+                <a:solidFill>
+                  <a:srgbClr val="2A363B"/>
+                </a:solidFill>
+              </a:rPr>
+              <a:t>Getamazednow AI  ·  A Getamazednow Company        </a:t>
+            </a:r>
+            <a:r>
               <a:rPr sz="900" b="0" i="0">
                 <a:solidFill>
                   <a:srgbClr val="8A97A0"/>
@@ -6916,6 +7194,30 @@
           </a:p>
         </p:txBody>
       </p:sp>
+      <p:pic>
+        <p:nvPicPr>
+          <p:cNvPr id="22" name="Picture 21" descr="mono_ink.png"/>
+          <p:cNvPicPr>
+            <a:picLocks noChangeAspect="1"/>
+          </p:cNvPicPr>
+          <p:nvPr/>
+        </p:nvPicPr>
+        <p:blipFill>
+          <a:blip r:embed="rId2"/>
+          <a:stretch>
+            <a:fillRect/>
+          </a:stretch>
+        </p:blipFill>
+        <p:spPr>
+          <a:xfrm>
+            <a:off x="201168" y="6528816"/>
+            <a:ext cx="182880" cy="182880"/>
+          </a:xfrm>
+          <a:prstGeom prst="rect">
+            <a:avLst/>
+          </a:prstGeom>
+        </p:spPr>
+      </p:pic>
     </p:spTree>
   </p:cSld>
   <p:clrMapOvr>
@@ -6942,50 +7244,30 @@
         <p:nvPr/>
       </p:nvGrpSpPr>
       <p:grpSpPr/>
-      <p:sp>
-        <p:nvSpPr>
-          <p:cNvPr id="2" name="Oval 1"/>
-          <p:cNvSpPr/>
-          <p:nvPr/>
-        </p:nvSpPr>
-        <p:spPr>
-          <a:xfrm>
-            <a:off x="-2194560" y="3931920"/>
-            <a:ext cx="5486400" cy="5486400"/>
-          </a:xfrm>
-          <a:prstGeom prst="ellipse">
-            <a:avLst/>
-          </a:prstGeom>
-          <a:solidFill>
-            <a:srgbClr val="3F474A"/>
-          </a:solidFill>
-          <a:ln>
-            <a:noFill/>
-          </a:ln>
-          <a:effectLst/>
-        </p:spPr>
-        <p:style>
-          <a:lnRef idx="1">
-            <a:schemeClr val="accent1"/>
-          </a:lnRef>
-          <a:fillRef idx="3">
-            <a:schemeClr val="accent1"/>
-          </a:fillRef>
-          <a:effectRef idx="2">
-            <a:schemeClr val="accent1"/>
-          </a:effectRef>
-          <a:fontRef idx="minor">
-            <a:schemeClr val="lt1"/>
-          </a:fontRef>
-        </p:style>
-        <p:txBody>
-          <a:bodyPr rtlCol="0" anchor="ctr"/>
-          <a:lstStyle/>
-          <a:p>
-            <a:pPr algn="ctr"/>
-          </a:p>
-        </p:txBody>
-      </p:sp>
+      <p:pic>
+        <p:nvPicPr>
+          <p:cNvPr id="7" name="Picture 6" descr="GenAIObsPPT-4.jpg"/>
+          <p:cNvPicPr>
+            <a:picLocks noChangeAspect="1"/>
+          </p:cNvPicPr>
+          <p:nvPr/>
+        </p:nvPicPr>
+        <p:blipFill>
+          <a:blip r:embed="rId2"/>
+          <a:stretch>
+            <a:fillRect/>
+          </a:stretch>
+        </p:blipFill>
+        <p:spPr>
+          <a:xfrm>
+            <a:off x="0" y="0"/>
+            <a:ext cx="12191695" cy="6858000"/>
+          </a:xfrm>
+          <a:prstGeom prst="rect">
+            <a:avLst/>
+          </a:prstGeom>
+        </p:spPr>
+      </p:pic>
       <p:sp>
         <p:nvSpPr>
           <p:cNvPr id="3" name="TextBox 2"/>
@@ -7138,6 +7420,74 @@
                 <a:latin typeface="Calibri"/>
               </a:rPr>
               <a:t>03 / 16</a:t>
+            </a:r>
+          </a:p>
+        </p:txBody>
+      </p:sp>
+      <p:pic>
+        <p:nvPicPr>
+          <p:cNvPr id="8" name="Picture 7" descr="mono_white.png"/>
+          <p:cNvPicPr>
+            <a:picLocks noChangeAspect="1"/>
+          </p:cNvPicPr>
+          <p:nvPr/>
+        </p:nvPicPr>
+        <p:blipFill>
+          <a:blip r:embed="rId3"/>
+          <a:stretch>
+            <a:fillRect/>
+          </a:stretch>
+        </p:blipFill>
+        <p:spPr>
+          <a:xfrm>
+            <a:off x="822960" y="6419088"/>
+            <a:ext cx="201168" cy="201168"/>
+          </a:xfrm>
+          <a:prstGeom prst="rect">
+            <a:avLst/>
+          </a:prstGeom>
+        </p:spPr>
+      </p:pic>
+      <p:sp>
+        <p:nvSpPr>
+          <p:cNvPr id="9" name="TextBox 8"/>
+          <p:cNvSpPr txBox="1"/>
+          <p:nvPr/>
+        </p:nvSpPr>
+        <p:spPr>
+          <a:xfrm>
+            <a:off x="1133856" y="6409944"/>
+            <a:ext cx="5943600" cy="256032"/>
+          </a:xfrm>
+          <a:prstGeom prst="rect">
+            <a:avLst/>
+          </a:prstGeom>
+          <a:noFill/>
+        </p:spPr>
+        <p:txBody>
+          <a:bodyPr wrap="square" anchor="ctr" lIns="0" rIns="0" tIns="0" bIns="0">
+            <a:spAutoFit/>
+          </a:bodyPr>
+          <a:lstStyle/>
+          <a:p>
+            <a:pPr algn="l"/>
+            <a:r>
+              <a:rPr sz="850" b="1">
+                <a:solidFill>
+                  <a:srgbClr val="A8A17B"/>
+                </a:solidFill>
+                <a:latin typeface="Poppins"/>
+              </a:rPr>
+              <a:t>Getamazednow AI</a:t>
+            </a:r>
+            <a:r>
+              <a:rPr sz="850" b="0">
+                <a:solidFill>
+                  <a:srgbClr val="A8A17B"/>
+                </a:solidFill>
+                <a:latin typeface="Inter"/>
+              </a:rPr>
+              <a:t>   ·   A Getamazednow Company</a:t>
             </a:r>
           </a:p>
         </p:txBody>
@@ -7312,6 +7662,15 @@
                 <a:spcPct val="115000"/>
               </a:lnSpc>
             </a:pPr>
+            <a:r>
+              <a:rPr lang="en-US" sz="800" b="1">
+                <a:latin typeface="Poppins"/>
+                <a:solidFill>
+                  <a:srgbClr val="2A363B"/>
+                </a:solidFill>
+              </a:rPr>
+              <a:t>Getamazednow AI  ·  A Getamazednow Company        </a:t>
+            </a:r>
             <a:r>
               <a:rPr sz="900" b="0" i="0">
                 <a:solidFill>
@@ -7658,6 +8017,30 @@
           </a:p>
         </p:txBody>
       </p:sp>
+      <p:pic>
+        <p:nvPicPr>
+          <p:cNvPr id="9" name="Picture 8" descr="mono_ink.png"/>
+          <p:cNvPicPr>
+            <a:picLocks noChangeAspect="1"/>
+          </p:cNvPicPr>
+          <p:nvPr/>
+        </p:nvPicPr>
+        <p:blipFill>
+          <a:blip r:embed="rId2"/>
+          <a:stretch>
+            <a:fillRect/>
+          </a:stretch>
+        </p:blipFill>
+        <p:spPr>
+          <a:xfrm>
+            <a:off x="201168" y="6528816"/>
+            <a:ext cx="182880" cy="182880"/>
+          </a:xfrm>
+          <a:prstGeom prst="rect">
+            <a:avLst/>
+          </a:prstGeom>
+        </p:spPr>
+      </p:pic>
     </p:spTree>
   </p:cSld>
   <p:clrMapOvr>
@@ -7829,6 +8212,15 @@
               </a:lnSpc>
             </a:pPr>
             <a:r>
+              <a:rPr lang="en-US" sz="800" b="1">
+                <a:latin typeface="Poppins"/>
+                <a:solidFill>
+                  <a:srgbClr val="2A363B"/>
+                </a:solidFill>
+              </a:rPr>
+              <a:t>Getamazednow AI  ·  A Getamazednow Company        </a:t>
+            </a:r>
+            <a:r>
               <a:rPr sz="900" b="0" i="0">
                 <a:solidFill>
                   <a:srgbClr val="8A97A0"/>
@@ -8194,6 +8586,30 @@
           </a:p>
         </p:txBody>
       </p:sp>
+      <p:pic>
+        <p:nvPicPr>
+          <p:cNvPr id="12" name="Picture 11" descr="mono_ink.png"/>
+          <p:cNvPicPr>
+            <a:picLocks noChangeAspect="1"/>
+          </p:cNvPicPr>
+          <p:nvPr/>
+        </p:nvPicPr>
+        <p:blipFill>
+          <a:blip r:embed="rId2"/>
+          <a:stretch>
+            <a:fillRect/>
+          </a:stretch>
+        </p:blipFill>
+        <p:spPr>
+          <a:xfrm>
+            <a:off x="201168" y="6528816"/>
+            <a:ext cx="182880" cy="182880"/>
+          </a:xfrm>
+          <a:prstGeom prst="rect">
+            <a:avLst/>
+          </a:prstGeom>
+        </p:spPr>
+      </p:pic>
     </p:spTree>
   </p:cSld>
   <p:clrMapOvr>
@@ -8365,6 +8781,15 @@
               </a:lnSpc>
             </a:pPr>
             <a:r>
+              <a:rPr lang="en-US" sz="800" b="1">
+                <a:latin typeface="Poppins"/>
+                <a:solidFill>
+                  <a:srgbClr val="2A363B"/>
+                </a:solidFill>
+              </a:rPr>
+              <a:t>Getamazednow AI  ·  A Getamazednow Company        </a:t>
+            </a:r>
+            <a:r>
               <a:rPr sz="900" b="0" i="0">
                 <a:solidFill>
                   <a:srgbClr val="8A97A0"/>
@@ -8940,6 +9365,30 @@
           </a:p>
         </p:txBody>
       </p:sp>
+      <p:pic>
+        <p:nvPicPr>
+          <p:cNvPr id="19" name="Picture 18" descr="mono_ink.png"/>
+          <p:cNvPicPr>
+            <a:picLocks noChangeAspect="1"/>
+          </p:cNvPicPr>
+          <p:nvPr/>
+        </p:nvPicPr>
+        <p:blipFill>
+          <a:blip r:embed="rId2"/>
+          <a:stretch>
+            <a:fillRect/>
+          </a:stretch>
+        </p:blipFill>
+        <p:spPr>
+          <a:xfrm>
+            <a:off x="201168" y="6528816"/>
+            <a:ext cx="182880" cy="182880"/>
+          </a:xfrm>
+          <a:prstGeom prst="rect">
+            <a:avLst/>
+          </a:prstGeom>
+        </p:spPr>
+      </p:pic>
     </p:spTree>
   </p:cSld>
   <p:clrMapOvr>
@@ -9111,6 +9560,15 @@
               </a:lnSpc>
             </a:pPr>
             <a:r>
+              <a:rPr lang="en-US" sz="800" b="1">
+                <a:latin typeface="Poppins"/>
+                <a:solidFill>
+                  <a:srgbClr val="2A363B"/>
+                </a:solidFill>
+              </a:rPr>
+              <a:t>Getamazednow AI  ·  A Getamazednow Company        </a:t>
+            </a:r>
+            <a:r>
               <a:rPr sz="900" b="0" i="0">
                 <a:solidFill>
                   <a:srgbClr val="8A97A0"/>
@@ -10211,6 +10669,30 @@
           </a:p>
         </p:txBody>
       </p:sp>
+      <p:pic>
+        <p:nvPicPr>
+          <p:cNvPr id="31" name="Picture 30" descr="mono_ink.png"/>
+          <p:cNvPicPr>
+            <a:picLocks noChangeAspect="1"/>
+          </p:cNvPicPr>
+          <p:nvPr/>
+        </p:nvPicPr>
+        <p:blipFill>
+          <a:blip r:embed="rId2"/>
+          <a:stretch>
+            <a:fillRect/>
+          </a:stretch>
+        </p:blipFill>
+        <p:spPr>
+          <a:xfrm>
+            <a:off x="201168" y="6528816"/>
+            <a:ext cx="182880" cy="182880"/>
+          </a:xfrm>
+          <a:prstGeom prst="rect">
+            <a:avLst/>
+          </a:prstGeom>
+        </p:spPr>
+      </p:pic>
     </p:spTree>
   </p:cSld>
   <p:clrMapOvr>
@@ -10237,50 +10719,30 @@
         <p:nvPr/>
       </p:nvGrpSpPr>
       <p:grpSpPr/>
-      <p:sp>
-        <p:nvSpPr>
-          <p:cNvPr id="2" name="Oval 1"/>
-          <p:cNvSpPr/>
-          <p:nvPr/>
-        </p:nvSpPr>
-        <p:spPr>
-          <a:xfrm>
-            <a:off x="-2194560" y="3931920"/>
-            <a:ext cx="5486400" cy="5486400"/>
-          </a:xfrm>
-          <a:prstGeom prst="ellipse">
-            <a:avLst/>
-          </a:prstGeom>
-          <a:solidFill>
-            <a:srgbClr val="3F474A"/>
-          </a:solidFill>
-          <a:ln>
-            <a:noFill/>
-          </a:ln>
-          <a:effectLst/>
-        </p:spPr>
-        <p:style>
-          <a:lnRef idx="1">
-            <a:schemeClr val="accent1"/>
-          </a:lnRef>
-          <a:fillRef idx="3">
-            <a:schemeClr val="accent1"/>
-          </a:fillRef>
-          <a:effectRef idx="2">
-            <a:schemeClr val="accent1"/>
-          </a:effectRef>
-          <a:fontRef idx="minor">
-            <a:schemeClr val="lt1"/>
-          </a:fontRef>
-        </p:style>
-        <p:txBody>
-          <a:bodyPr rtlCol="0" anchor="ctr"/>
-          <a:lstStyle/>
-          <a:p>
-            <a:pPr algn="ctr"/>
-          </a:p>
-        </p:txBody>
-      </p:sp>
+      <p:pic>
+        <p:nvPicPr>
+          <p:cNvPr id="7" name="Picture 6" descr="GenAIObsPPT-4.jpg"/>
+          <p:cNvPicPr>
+            <a:picLocks noChangeAspect="1"/>
+          </p:cNvPicPr>
+          <p:nvPr/>
+        </p:nvPicPr>
+        <p:blipFill>
+          <a:blip r:embed="rId2"/>
+          <a:stretch>
+            <a:fillRect/>
+          </a:stretch>
+        </p:blipFill>
+        <p:spPr>
+          <a:xfrm>
+            <a:off x="0" y="0"/>
+            <a:ext cx="12191695" cy="6858000"/>
+          </a:xfrm>
+          <a:prstGeom prst="rect">
+            <a:avLst/>
+          </a:prstGeom>
+        </p:spPr>
+      </p:pic>
       <p:sp>
         <p:nvSpPr>
           <p:cNvPr id="3" name="TextBox 2"/>
@@ -10433,6 +10895,74 @@
                 <a:latin typeface="Calibri"/>
               </a:rPr>
               <a:t>08 / 16</a:t>
+            </a:r>
+          </a:p>
+        </p:txBody>
+      </p:sp>
+      <p:pic>
+        <p:nvPicPr>
+          <p:cNvPr id="8" name="Picture 7" descr="mono_white.png"/>
+          <p:cNvPicPr>
+            <a:picLocks noChangeAspect="1"/>
+          </p:cNvPicPr>
+          <p:nvPr/>
+        </p:nvPicPr>
+        <p:blipFill>
+          <a:blip r:embed="rId3"/>
+          <a:stretch>
+            <a:fillRect/>
+          </a:stretch>
+        </p:blipFill>
+        <p:spPr>
+          <a:xfrm>
+            <a:off x="822960" y="6419088"/>
+            <a:ext cx="201168" cy="201168"/>
+          </a:xfrm>
+          <a:prstGeom prst="rect">
+            <a:avLst/>
+          </a:prstGeom>
+        </p:spPr>
+      </p:pic>
+      <p:sp>
+        <p:nvSpPr>
+          <p:cNvPr id="9" name="TextBox 8"/>
+          <p:cNvSpPr txBox="1"/>
+          <p:nvPr/>
+        </p:nvSpPr>
+        <p:spPr>
+          <a:xfrm>
+            <a:off x="1133856" y="6409944"/>
+            <a:ext cx="5943600" cy="256032"/>
+          </a:xfrm>
+          <a:prstGeom prst="rect">
+            <a:avLst/>
+          </a:prstGeom>
+          <a:noFill/>
+        </p:spPr>
+        <p:txBody>
+          <a:bodyPr wrap="square" anchor="ctr" lIns="0" rIns="0" tIns="0" bIns="0">
+            <a:spAutoFit/>
+          </a:bodyPr>
+          <a:lstStyle/>
+          <a:p>
+            <a:pPr algn="l"/>
+            <a:r>
+              <a:rPr sz="850" b="1">
+                <a:solidFill>
+                  <a:srgbClr val="A8A17B"/>
+                </a:solidFill>
+                <a:latin typeface="Poppins"/>
+              </a:rPr>
+              <a:t>Getamazednow AI</a:t>
+            </a:r>
+            <a:r>
+              <a:rPr sz="850" b="0">
+                <a:solidFill>
+                  <a:srgbClr val="A8A17B"/>
+                </a:solidFill>
+                <a:latin typeface="Inter"/>
+              </a:rPr>
+              <a:t>   ·   A Getamazednow Company</a:t>
             </a:r>
           </a:p>
         </p:txBody>
@@ -10608,6 +11138,15 @@
               </a:lnSpc>
             </a:pPr>
             <a:r>
+              <a:rPr lang="en-US" sz="800" b="1">
+                <a:latin typeface="Poppins"/>
+                <a:solidFill>
+                  <a:srgbClr val="2A363B"/>
+                </a:solidFill>
+              </a:rPr>
+              <a:t>Getamazednow AI  ·  A Getamazednow Company        </a:t>
+            </a:r>
+            <a:r>
               <a:rPr sz="900" b="0" i="0">
                 <a:solidFill>
                   <a:srgbClr val="8A97A0"/>
@@ -10637,6 +11176,30 @@
           <a:xfrm>
             <a:off x="2665120" y="1417320"/>
             <a:ext cx="6831279" cy="4892040"/>
+          </a:xfrm>
+          <a:prstGeom prst="rect">
+            <a:avLst/>
+          </a:prstGeom>
+        </p:spPr>
+      </p:pic>
+      <p:pic>
+        <p:nvPicPr>
+          <p:cNvPr id="7" name="Picture 6" descr="mono_ink.png"/>
+          <p:cNvPicPr>
+            <a:picLocks noChangeAspect="1"/>
+          </p:cNvPicPr>
+          <p:nvPr/>
+        </p:nvPicPr>
+        <p:blipFill>
+          <a:blip r:embed="rId3"/>
+          <a:stretch>
+            <a:fillRect/>
+          </a:stretch>
+        </p:blipFill>
+        <p:spPr>
+          <a:xfrm>
+            <a:off x="201168" y="6528816"/>
+            <a:ext cx="182880" cy="182880"/>
           </a:xfrm>
           <a:prstGeom prst="rect">
             <a:avLst/>

</xml_diff>